<commit_message>
Module 3 deck: title shows due date October 4 (user edit), PDF re-exported
Co-Authored-By: Claude Opus 5.5 <noreply@anthropic.com>
</commit_message>
<xml_diff>
--- a/module-03-industry-transformation/Bandari_Ruthvik_Nath_Module3_AI_Industry_Transformation.pptx
+++ b/module-03-industry-transformation/Bandari_Ruthvik_Nath_Module3_AI_Industry_Transformation.pptx
@@ -4,19 +4,22 @@
   <p:sldMasterIdLst>
     <p:sldMasterId id="2147483648" r:id="rId1"/>
   </p:sldMasterIdLst>
+  <p:notesMasterIdLst>
+    <p:notesMasterId r:id="rId12"/>
+  </p:notesMasterIdLst>
   <p:sldIdLst>
-    <p:sldId id="256" r:id="rId7"/>
-    <p:sldId id="257" r:id="rId9"/>
-    <p:sldId id="258" r:id="rId10"/>
-    <p:sldId id="259" r:id="rId11"/>
-    <p:sldId id="260" r:id="rId12"/>
-    <p:sldId id="261" r:id="rId13"/>
-    <p:sldId id="262" r:id="rId14"/>
-    <p:sldId id="263" r:id="rId15"/>
-    <p:sldId id="264" r:id="rId16"/>
-    <p:sldId id="265" r:id="rId17"/>
+    <p:sldId id="256" r:id="rId2"/>
+    <p:sldId id="257" r:id="rId3"/>
+    <p:sldId id="258" r:id="rId4"/>
+    <p:sldId id="259" r:id="rId5"/>
+    <p:sldId id="260" r:id="rId6"/>
+    <p:sldId id="261" r:id="rId7"/>
+    <p:sldId id="262" r:id="rId8"/>
+    <p:sldId id="263" r:id="rId9"/>
+    <p:sldId id="264" r:id="rId10"/>
+    <p:sldId id="265" r:id="rId11"/>
   </p:sldIdLst>
-  <p:sldSz cx="12191695" cy="6858000" type="screen4x3"/>
+  <p:sldSz cx="12192000" cy="6858000"/>
   <p:notesSz cx="6858000" cy="9144000"/>
   <p:defaultTextStyle>
     <a:defPPr>
@@ -113,12 +116,31 @@
       </a:defRPr>
     </a:lvl9pPr>
   </p:defaultTextStyle>
+  <p:extLst>
+    <p:ext uri="{EFAFB233-063F-42B5-8137-9DF3F51BA10A}">
+      <p15:sldGuideLst xmlns:p15="http://schemas.microsoft.com/office/powerpoint/2012/main">
+        <p15:guide id="1" orient="horz" pos="2160">
+          <p15:clr>
+            <a:srgbClr val="A4A3A4"/>
+          </p15:clr>
+        </p15:guide>
+        <p15:guide id="2" pos="2880">
+          <p15:clr>
+            <a:srgbClr val="A4A3A4"/>
+          </p15:clr>
+        </p15:guide>
+      </p15:sldGuideLst>
+    </p:ext>
+  </p:extLst>
 </p:presentation>
 </file>
 
 <file path=ppt/charts/chart1.xml><?xml version="1.0" encoding="utf-8"?>
-<c:chartSpace xmlns:c="http://schemas.openxmlformats.org/drawingml/2006/chart" xmlns:a="http://schemas.openxmlformats.org/drawingml/2006/main" xmlns:r="http://schemas.openxmlformats.org/officeDocument/2006/relationships">
+<c:chartSpace xmlns:c="http://schemas.openxmlformats.org/drawingml/2006/chart" xmlns:a="http://schemas.openxmlformats.org/drawingml/2006/main" xmlns:r="http://schemas.openxmlformats.org/officeDocument/2006/relationships" xmlns:c16r2="http://schemas.microsoft.com/office/drawing/2015/06/chart">
   <c:date1904 val="0"/>
+  <c:lang val="en-US"/>
+  <c:roundedCorners val="1"/>
+  <c:style val="2"/>
   <c:chart>
     <c:title>
       <c:tx>
@@ -127,7 +149,7 @@
           <a:lstStyle/>
           <a:p>
             <a:r>
-              <a:rPr sz="1400" b="1">
+              <a:rPr lang="en-US" sz="1400" b="1">
                 <a:solidFill>
                   <a:srgbClr val="0F1B2D"/>
                 </a:solidFill>
@@ -138,14 +160,15 @@
           </a:p>
         </c:rich>
       </c:tx>
-      <c:layout/>
       <c:overlay val="0"/>
     </c:title>
     <c:autoTitleDeleted val="0"/>
     <c:plotArea>
+      <c:layout/>
       <c:barChart>
         <c:barDir val="col"/>
         <c:grouping val="clustered"/>
+        <c:varyColors val="1"/>
         <c:ser>
           <c:idx val="0"/>
           <c:order val="0"/>
@@ -160,22 +183,75 @@
               </c:strCache>
             </c:strRef>
           </c:tx>
+          <c:invertIfNegative val="1"/>
           <c:dPt>
             <c:idx val="0"/>
+            <c:invertIfNegative val="1"/>
+            <c:bubble3D val="0"/>
             <c:spPr>
               <a:solidFill>
                 <a:srgbClr val="9AA3AF"/>
               </a:solidFill>
             </c:spPr>
+            <c:extLst>
+              <c:ext xmlns:c16="http://schemas.microsoft.com/office/drawing/2014/chart" uri="{C3380CC4-5D6E-409C-BE32-E72D297353CC}">
+                <c16:uniqueId val="{00000001-8D15-CB43-9408-37BF84EA66D4}"/>
+              </c:ext>
+            </c:extLst>
           </c:dPt>
           <c:dPt>
             <c:idx val="1"/>
+            <c:invertIfNegative val="1"/>
+            <c:bubble3D val="0"/>
             <c:spPr>
               <a:solidFill>
                 <a:srgbClr val="1F5FAD"/>
               </a:solidFill>
             </c:spPr>
+            <c:extLst>
+              <c:ext xmlns:c16="http://schemas.microsoft.com/office/drawing/2014/chart" uri="{C3380CC4-5D6E-409C-BE32-E72D297353CC}">
+                <c16:uniqueId val="{00000003-8D15-CB43-9408-37BF84EA66D4}"/>
+              </c:ext>
+            </c:extLst>
           </c:dPt>
+          <c:dLbls>
+            <c:numFmt formatCode="&quot;$&quot;0.00" sourceLinked="0"/>
+            <c:spPr>
+              <a:noFill/>
+              <a:ln>
+                <a:noFill/>
+              </a:ln>
+              <a:effectLst/>
+            </c:spPr>
+            <c:txPr>
+              <a:bodyPr/>
+              <a:lstStyle/>
+              <a:p>
+                <a:pPr>
+                  <a:defRPr sz="1600" b="1">
+                    <a:solidFill>
+                      <a:srgbClr val="1F2937"/>
+                    </a:solidFill>
+                    <a:latin typeface="Calibri"/>
+                  </a:defRPr>
+                </a:pPr>
+                <a:endParaRPr lang="en-US"/>
+              </a:p>
+            </c:txPr>
+            <c:dLblPos val="outEnd"/>
+            <c:showLegendKey val="0"/>
+            <c:showVal val="1"/>
+            <c:showCatName val="0"/>
+            <c:showSerName val="0"/>
+            <c:showPercent val="0"/>
+            <c:showBubbleSize val="0"/>
+            <c:showLeaderLines val="0"/>
+            <c:extLst>
+              <c:ext xmlns:c15="http://schemas.microsoft.com/office/drawing/2012/chart" uri="{CE6537A1-D6FC-4f65-9D91-7224C49458BB}">
+                <c15:showLeaderLines val="0"/>
+              </c:ext>
+            </c:extLst>
+          </c:dLbls>
           <c:cat>
             <c:strRef>
               <c:f>Sheet1!$A$2:$A$3</c:f>
@@ -205,23 +281,13 @@
               </c:numCache>
             </c:numRef>
           </c:val>
+          <c:extLst>
+            <c:ext xmlns:c16="http://schemas.microsoft.com/office/drawing/2014/chart" uri="{C3380CC4-5D6E-409C-BE32-E72D297353CC}">
+              <c16:uniqueId val="{00000004-8D15-CB43-9408-37BF84EA66D4}"/>
+            </c:ext>
+          </c:extLst>
         </c:ser>
         <c:dLbls>
-          <c:numFmt formatCode="&quot;$&quot;0.00" sourceLinked="0"/>
-          <c:txPr>
-            <a:bodyPr/>
-            <a:lstStyle/>
-            <a:p>
-              <a:pPr>
-                <a:defRPr sz="1600" b="1">
-                  <a:solidFill>
-                    <a:srgbClr val="1F2937"/>
-                  </a:solidFill>
-                  <a:latin typeface="Calibri"/>
-                </a:defRPr>
-              </a:pPr>
-            </a:p>
-          </c:txPr>
           <c:dLblPos val="outEnd"/>
           <c:showLegendKey val="0"/>
           <c:showVal val="1"/>
@@ -229,7 +295,6 @@
           <c:showSerName val="0"/>
           <c:showPercent val="0"/>
           <c:showBubbleSize val="0"/>
-          <c:showLeaderLines val="1"/>
         </c:dLbls>
         <c:gapWidth val="70"/>
         <c:axId val="-2068027336"/>
@@ -242,6 +307,7 @@
         </c:scaling>
         <c:delete val="0"/>
         <c:axPos val="b"/>
+        <c:numFmt formatCode="General" sourceLinked="0"/>
         <c:majorTickMark val="out"/>
         <c:minorTickMark val="none"/>
         <c:tickLblPos val="nextTo"/>
@@ -264,6 +330,7 @@
                 <a:latin typeface="Calibri"/>
               </a:defRPr>
             </a:pPr>
+            <a:endParaRPr lang="en-US"/>
           </a:p>
         </c:txPr>
         <c:crossAx val="-2113994440"/>
@@ -276,19 +343,24 @@
       <c:valAx>
         <c:axId val="-2113994440"/>
         <c:scaling>
+          <c:orientation val="minMax"/>
           <c:max val="6.6"/>
-          <c:min val="0.0"/>
+          <c:min val="0"/>
         </c:scaling>
-        <c:delete/>
+        <c:delete val="1"/>
         <c:axPos val="l"/>
+        <c:numFmt formatCode="General" sourceLinked="1"/>
         <c:majorTickMark val="out"/>
         <c:minorTickMark val="none"/>
         <c:tickLblPos val="nextTo"/>
         <c:crossAx val="-2068027336"/>
         <c:crosses val="autoZero"/>
+        <c:crossBetween val="between"/>
       </c:valAx>
     </c:plotArea>
+    <c:plotVisOnly val="1"/>
     <c:dispBlanksAs val="gap"/>
+    <c:showDLblsOverMax val="1"/>
   </c:chart>
   <c:txPr>
     <a:bodyPr/>
@@ -307,8 +379,11 @@
 </file>
 
 <file path=ppt/charts/chart2.xml><?xml version="1.0" encoding="utf-8"?>
-<c:chartSpace xmlns:c="http://schemas.openxmlformats.org/drawingml/2006/chart" xmlns:a="http://schemas.openxmlformats.org/drawingml/2006/main" xmlns:r="http://schemas.openxmlformats.org/officeDocument/2006/relationships">
+<c:chartSpace xmlns:c="http://schemas.openxmlformats.org/drawingml/2006/chart" xmlns:a="http://schemas.openxmlformats.org/drawingml/2006/main" xmlns:r="http://schemas.openxmlformats.org/officeDocument/2006/relationships" xmlns:c16r2="http://schemas.microsoft.com/office/drawing/2015/06/chart">
   <c:date1904 val="0"/>
+  <c:lang val="en-US"/>
+  <c:roundedCorners val="1"/>
+  <c:style val="2"/>
   <c:chart>
     <c:title>
       <c:tx>
@@ -317,7 +392,7 @@
           <a:lstStyle/>
           <a:p>
             <a:r>
-              <a:rPr sz="1400" b="1">
+              <a:rPr lang="en-US" sz="1400" b="1">
                 <a:solidFill>
                   <a:srgbClr val="0F1B2D"/>
                 </a:solidFill>
@@ -328,14 +403,15 @@
           </a:p>
         </c:rich>
       </c:tx>
-      <c:layout/>
       <c:overlay val="0"/>
     </c:title>
     <c:autoTitleDeleted val="0"/>
     <c:plotArea>
+      <c:layout/>
       <c:barChart>
         <c:barDir val="col"/>
         <c:grouping val="clustered"/>
+        <c:varyColors val="1"/>
         <c:ser>
           <c:idx val="0"/>
           <c:order val="0"/>
@@ -350,22 +426,75 @@
               </c:strCache>
             </c:strRef>
           </c:tx>
+          <c:invertIfNegative val="1"/>
           <c:dPt>
             <c:idx val="0"/>
+            <c:invertIfNegative val="1"/>
+            <c:bubble3D val="0"/>
             <c:spPr>
               <a:solidFill>
                 <a:srgbClr val="9AA3AF"/>
               </a:solidFill>
             </c:spPr>
+            <c:extLst>
+              <c:ext xmlns:c16="http://schemas.microsoft.com/office/drawing/2014/chart" uri="{C3380CC4-5D6E-409C-BE32-E72D297353CC}">
+                <c16:uniqueId val="{00000001-7632-3747-836D-320CA631D3DB}"/>
+              </c:ext>
+            </c:extLst>
           </c:dPt>
           <c:dPt>
             <c:idx val="1"/>
+            <c:invertIfNegative val="1"/>
+            <c:bubble3D val="0"/>
             <c:spPr>
               <a:solidFill>
                 <a:srgbClr val="1F5FAD"/>
               </a:solidFill>
             </c:spPr>
+            <c:extLst>
+              <c:ext xmlns:c16="http://schemas.microsoft.com/office/drawing/2014/chart" uri="{C3380CC4-5D6E-409C-BE32-E72D297353CC}">
+                <c16:uniqueId val="{00000003-7632-3747-836D-320CA631D3DB}"/>
+              </c:ext>
+            </c:extLst>
           </c:dPt>
+          <c:dLbls>
+            <c:numFmt formatCode="0" sourceLinked="0"/>
+            <c:spPr>
+              <a:noFill/>
+              <a:ln>
+                <a:noFill/>
+              </a:ln>
+              <a:effectLst/>
+            </c:spPr>
+            <c:txPr>
+              <a:bodyPr/>
+              <a:lstStyle/>
+              <a:p>
+                <a:pPr>
+                  <a:defRPr sz="1600" b="1">
+                    <a:solidFill>
+                      <a:srgbClr val="1F2937"/>
+                    </a:solidFill>
+                    <a:latin typeface="Calibri"/>
+                  </a:defRPr>
+                </a:pPr>
+                <a:endParaRPr lang="en-US"/>
+              </a:p>
+            </c:txPr>
+            <c:dLblPos val="outEnd"/>
+            <c:showLegendKey val="0"/>
+            <c:showVal val="1"/>
+            <c:showCatName val="0"/>
+            <c:showSerName val="0"/>
+            <c:showPercent val="0"/>
+            <c:showBubbleSize val="0"/>
+            <c:showLeaderLines val="0"/>
+            <c:extLst>
+              <c:ext xmlns:c15="http://schemas.microsoft.com/office/drawing/2012/chart" uri="{CE6537A1-D6FC-4f65-9D91-7224C49458BB}">
+                <c15:showLeaderLines val="0"/>
+              </c:ext>
+            </c:extLst>
+          </c:dLbls>
           <c:cat>
             <c:strRef>
               <c:f>Sheet1!$A$2:$A$3</c:f>
@@ -395,23 +524,13 @@
               </c:numCache>
             </c:numRef>
           </c:val>
+          <c:extLst>
+            <c:ext xmlns:c16="http://schemas.microsoft.com/office/drawing/2014/chart" uri="{C3380CC4-5D6E-409C-BE32-E72D297353CC}">
+              <c16:uniqueId val="{00000004-7632-3747-836D-320CA631D3DB}"/>
+            </c:ext>
+          </c:extLst>
         </c:ser>
         <c:dLbls>
-          <c:numFmt formatCode="0" sourceLinked="0"/>
-          <c:txPr>
-            <a:bodyPr/>
-            <a:lstStyle/>
-            <a:p>
-              <a:pPr>
-                <a:defRPr sz="1600" b="1">
-                  <a:solidFill>
-                    <a:srgbClr val="1F2937"/>
-                  </a:solidFill>
-                  <a:latin typeface="Calibri"/>
-                </a:defRPr>
-              </a:pPr>
-            </a:p>
-          </c:txPr>
           <c:dLblPos val="outEnd"/>
           <c:showLegendKey val="0"/>
           <c:showVal val="1"/>
@@ -419,7 +538,6 @@
           <c:showSerName val="0"/>
           <c:showPercent val="0"/>
           <c:showBubbleSize val="0"/>
-          <c:showLeaderLines val="1"/>
         </c:dLbls>
         <c:gapWidth val="70"/>
         <c:axId val="-2068027336"/>
@@ -432,6 +550,7 @@
         </c:scaling>
         <c:delete val="0"/>
         <c:axPos val="b"/>
+        <c:numFmt formatCode="General" sourceLinked="0"/>
         <c:majorTickMark val="out"/>
         <c:minorTickMark val="none"/>
         <c:tickLblPos val="nextTo"/>
@@ -454,6 +573,7 @@
                 <a:latin typeface="Calibri"/>
               </a:defRPr>
             </a:pPr>
+            <a:endParaRPr lang="en-US"/>
           </a:p>
         </c:txPr>
         <c:crossAx val="-2113994440"/>
@@ -466,19 +586,24 @@
       <c:valAx>
         <c:axId val="-2113994440"/>
         <c:scaling>
-          <c:max val="340.0"/>
-          <c:min val="0.0"/>
+          <c:orientation val="minMax"/>
+          <c:max val="340"/>
+          <c:min val="0"/>
         </c:scaling>
-        <c:delete/>
+        <c:delete val="1"/>
         <c:axPos val="l"/>
+        <c:numFmt formatCode="General" sourceLinked="1"/>
         <c:majorTickMark val="out"/>
         <c:minorTickMark val="none"/>
         <c:tickLblPos val="nextTo"/>
         <c:crossAx val="-2068027336"/>
         <c:crosses val="autoZero"/>
+        <c:crossBetween val="between"/>
       </c:valAx>
     </c:plotArea>
+    <c:plotVisOnly val="1"/>
     <c:dispBlanksAs val="gap"/>
+    <c:showDLblsOverMax val="1"/>
   </c:chart>
   <c:txPr>
     <a:bodyPr/>
@@ -497,7 +622,7 @@
 </file>
 
 <file path=ppt/notesMasters/notesMaster1.xml><?xml version="1.0" encoding="utf-8"?>
-<p:notesMaster xmlns:a="http://schemas.openxmlformats.org/drawingml/2006/main" xmlns:p="http://schemas.openxmlformats.org/presentationml/2006/main" xmlns:r="http://schemas.openxmlformats.org/officeDocument/2006/relationships">
+<p:notesMaster xmlns:a="http://schemas.openxmlformats.org/drawingml/2006/main" xmlns:r="http://schemas.openxmlformats.org/officeDocument/2006/relationships" xmlns:p="http://schemas.openxmlformats.org/presentationml/2006/main">
   <p:cSld>
     <p:bg>
       <p:bgRef idx="1001">
@@ -518,241 +643,16 @@
           <a:chExt cx="0" cy="0"/>
         </a:xfrm>
       </p:grpSpPr>
-      <p:sp>
-        <p:nvSpPr>
-          <p:cNvPr id="2" name="Header Placeholder 1"/>
-          <p:cNvSpPr>
-            <a:spLocks noGrp="1"/>
-          </p:cNvSpPr>
-          <p:nvPr>
-            <p:ph type="hdr" sz="quarter"/>
-          </p:nvPr>
-        </p:nvSpPr>
-        <p:spPr>
-          <a:xfrm>
-            <a:off x="0" y="0"/>
-            <a:ext cx="2971800" cy="457200"/>
-          </a:xfrm>
-          <a:prstGeom prst="rect">
-            <a:avLst/>
-          </a:prstGeom>
-        </p:spPr>
-        <p:txBody>
-          <a:bodyPr vert="horz" lIns="91440" tIns="45720" rIns="91440" bIns="45720" rtlCol="0"/>
-          <a:lstStyle>
-            <a:lvl1pPr algn="l">
-              <a:defRPr sz="1200"/>
-            </a:lvl1pPr>
-          </a:lstStyle>
-          <a:p>
-            <a:endParaRPr lang="en-US"/>
-          </a:p>
-        </p:txBody>
-      </p:sp>
-      <p:sp>
-        <p:nvSpPr>
-          <p:cNvPr id="3" name="Date Placeholder 2"/>
-          <p:cNvSpPr>
-            <a:spLocks noGrp="1"/>
-          </p:cNvSpPr>
-          <p:nvPr>
-            <p:ph type="dt" idx="1"/>
-          </p:nvPr>
-        </p:nvSpPr>
-        <p:spPr>
-          <a:xfrm>
-            <a:off x="3884613" y="0"/>
-            <a:ext cx="2971800" cy="457200"/>
-          </a:xfrm>
-          <a:prstGeom prst="rect">
-            <a:avLst/>
-          </a:prstGeom>
-        </p:spPr>
-        <p:txBody>
-          <a:bodyPr vert="horz" lIns="91440" tIns="45720" rIns="91440" bIns="45720" rtlCol="0"/>
-          <a:lstStyle>
-            <a:lvl1pPr algn="r">
-              <a:defRPr sz="1200"/>
-            </a:lvl1pPr>
-          </a:lstStyle>
-          <a:p>
-            <a:fld id="{0F89C1C7-3DCD-1040-A9CF-14679D8B5DDD}" type="datetimeFigureOut">
-              <a:rPr lang="en-US" smtClean="0"/>
-              <a:t>10/17/16</a:t>
-            </a:fld>
-            <a:endParaRPr lang="en-US"/>
-          </a:p>
-        </p:txBody>
-      </p:sp>
-      <p:sp>
-        <p:nvSpPr>
-          <p:cNvPr id="4" name="Slide Image Placeholder 3"/>
-          <p:cNvSpPr>
-            <a:spLocks noGrp="1" noRot="1" noChangeAspect="1"/>
-          </p:cNvSpPr>
-          <p:nvPr>
-            <p:ph type="sldImg" idx="2"/>
-          </p:nvPr>
-        </p:nvSpPr>
-        <p:spPr>
-          <a:xfrm>
-            <a:off x="1143000" y="685800"/>
-            <a:ext cx="4572000" cy="3429000"/>
-          </a:xfrm>
-          <a:prstGeom prst="rect">
-            <a:avLst/>
-          </a:prstGeom>
-          <a:noFill/>
-          <a:ln w="12700">
-            <a:solidFill>
-              <a:prstClr val="black"/>
-            </a:solidFill>
-          </a:ln>
-        </p:spPr>
-        <p:txBody>
-          <a:bodyPr vert="horz" lIns="91440" tIns="45720" rIns="91440" bIns="45720" rtlCol="0" anchor="ctr"/>
-          <a:lstStyle/>
-          <a:p>
-            <a:endParaRPr lang="en-US"/>
-          </a:p>
-        </p:txBody>
-      </p:sp>
-      <p:sp>
-        <p:nvSpPr>
-          <p:cNvPr id="5" name="Notes Placeholder 4"/>
-          <p:cNvSpPr>
-            <a:spLocks noGrp="1"/>
-          </p:cNvSpPr>
-          <p:nvPr>
-            <p:ph type="body" sz="quarter" idx="3"/>
-          </p:nvPr>
-        </p:nvSpPr>
-        <p:spPr>
-          <a:xfrm>
-            <a:off x="685800" y="4343400"/>
-            <a:ext cx="5486400" cy="4114800"/>
-          </a:xfrm>
-          <a:prstGeom prst="rect">
-            <a:avLst/>
-          </a:prstGeom>
-        </p:spPr>
-        <p:txBody>
-          <a:bodyPr vert="horz" lIns="91440" tIns="45720" rIns="91440" bIns="45720" rtlCol="0"/>
-          <a:lstStyle/>
-          <a:p>
-            <a:pPr lvl="0"/>
-            <a:r>
-              <a:rPr lang="en-US" smtClean="0"/>
-              <a:t>Click to edit Master text styles</a:t>
-            </a:r>
-          </a:p>
-          <a:p>
-            <a:pPr lvl="1"/>
-            <a:r>
-              <a:rPr lang="en-US" smtClean="0"/>
-              <a:t>Second level</a:t>
-            </a:r>
-          </a:p>
-          <a:p>
-            <a:pPr lvl="2"/>
-            <a:r>
-              <a:rPr lang="en-US" smtClean="0"/>
-              <a:t>Third level</a:t>
-            </a:r>
-          </a:p>
-          <a:p>
-            <a:pPr lvl="3"/>
-            <a:r>
-              <a:rPr lang="en-US" smtClean="0"/>
-              <a:t>Fourth level</a:t>
-            </a:r>
-          </a:p>
-          <a:p>
-            <a:pPr lvl="4"/>
-            <a:r>
-              <a:rPr lang="en-US" smtClean="0"/>
-              <a:t>Fifth level</a:t>
-            </a:r>
-            <a:endParaRPr lang="en-US"/>
-          </a:p>
-        </p:txBody>
-      </p:sp>
-      <p:sp>
-        <p:nvSpPr>
-          <p:cNvPr id="6" name="Footer Placeholder 5"/>
-          <p:cNvSpPr>
-            <a:spLocks noGrp="1"/>
-          </p:cNvSpPr>
-          <p:nvPr>
-            <p:ph type="ftr" sz="quarter" idx="4"/>
-          </p:nvPr>
-        </p:nvSpPr>
-        <p:spPr>
-          <a:xfrm>
-            <a:off x="0" y="8685213"/>
-            <a:ext cx="2971800" cy="457200"/>
-          </a:xfrm>
-          <a:prstGeom prst="rect">
-            <a:avLst/>
-          </a:prstGeom>
-        </p:spPr>
-        <p:txBody>
-          <a:bodyPr vert="horz" lIns="91440" tIns="45720" rIns="91440" bIns="45720" rtlCol="0" anchor="b"/>
-          <a:lstStyle>
-            <a:lvl1pPr algn="l">
-              <a:defRPr sz="1200"/>
-            </a:lvl1pPr>
-          </a:lstStyle>
-          <a:p>
-            <a:endParaRPr lang="en-US"/>
-          </a:p>
-        </p:txBody>
-      </p:sp>
-      <p:sp>
-        <p:nvSpPr>
-          <p:cNvPr id="7" name="Slide Number Placeholder 6"/>
-          <p:cNvSpPr>
-            <a:spLocks noGrp="1"/>
-          </p:cNvSpPr>
-          <p:nvPr>
-            <p:ph type="sldNum" sz="quarter" idx="5"/>
-          </p:nvPr>
-        </p:nvSpPr>
-        <p:spPr>
-          <a:xfrm>
-            <a:off x="3884613" y="8685213"/>
-            <a:ext cx="2971800" cy="457200"/>
-          </a:xfrm>
-          <a:prstGeom prst="rect">
-            <a:avLst/>
-          </a:prstGeom>
-        </p:spPr>
-        <p:txBody>
-          <a:bodyPr vert="horz" lIns="91440" tIns="45720" rIns="91440" bIns="45720" rtlCol="0" anchor="b"/>
-          <a:lstStyle>
-            <a:lvl1pPr algn="r">
-              <a:defRPr sz="1200"/>
-            </a:lvl1pPr>
-          </a:lstStyle>
-          <a:p>
-            <a:fld id="{BB5E49A5-4136-284D-997B-48E1D791AD67}" type="slidenum">
-              <a:rPr lang="en-US" smtClean="0"/>
-              <a:t>‹#›</a:t>
-            </a:fld>
-            <a:endParaRPr lang="en-US"/>
-          </a:p>
-        </p:txBody>
-      </p:sp>
     </p:spTree>
     <p:extLst>
       <p:ext uri="{BB962C8B-B14F-4D97-AF65-F5344CB8AC3E}">
-        <p14:creationId xmlns:p14="http://schemas.microsoft.com/office/powerpoint/2010/main" val="2623252185"/>
+        <p14:creationId xmlns:p14="http://schemas.microsoft.com/office/powerpoint/2010/main" val="3802037284"/>
       </p:ext>
     </p:extLst>
   </p:cSld>
   <p:clrMap bg1="lt1" tx1="dk1" bg2="lt2" tx2="dk2" accent1="accent1" accent2="accent2" accent3="accent3" accent4="accent4" accent5="accent5" accent6="accent6" hlink="hlink" folHlink="folHlink"/>
   <p:notesStyle>
-    <a:lvl1pPr marL="0" algn="l" defTabSz="457200" rtl="0" eaLnBrk="1" latinLnBrk="0" hangingPunct="1">
+    <a:lvl1pPr marL="0" algn="l" defTabSz="914400" rtl="0" eaLnBrk="1" latinLnBrk="0" hangingPunct="1">
       <a:defRPr sz="1200" kern="1200">
         <a:solidFill>
           <a:schemeClr val="tx1"/>
@@ -762,7 +662,7 @@
         <a:cs typeface="+mn-cs"/>
       </a:defRPr>
     </a:lvl1pPr>
-    <a:lvl2pPr marL="457200" algn="l" defTabSz="457200" rtl="0" eaLnBrk="1" latinLnBrk="0" hangingPunct="1">
+    <a:lvl2pPr marL="457200" algn="l" defTabSz="914400" rtl="0" eaLnBrk="1" latinLnBrk="0" hangingPunct="1">
       <a:defRPr sz="1200" kern="1200">
         <a:solidFill>
           <a:schemeClr val="tx1"/>
@@ -772,7 +672,7 @@
         <a:cs typeface="+mn-cs"/>
       </a:defRPr>
     </a:lvl2pPr>
-    <a:lvl3pPr marL="914400" algn="l" defTabSz="457200" rtl="0" eaLnBrk="1" latinLnBrk="0" hangingPunct="1">
+    <a:lvl3pPr marL="914400" algn="l" defTabSz="914400" rtl="0" eaLnBrk="1" latinLnBrk="0" hangingPunct="1">
       <a:defRPr sz="1200" kern="1200">
         <a:solidFill>
           <a:schemeClr val="tx1"/>
@@ -782,7 +682,7 @@
         <a:cs typeface="+mn-cs"/>
       </a:defRPr>
     </a:lvl3pPr>
-    <a:lvl4pPr marL="1371600" algn="l" defTabSz="457200" rtl="0" eaLnBrk="1" latinLnBrk="0" hangingPunct="1">
+    <a:lvl4pPr marL="1371600" algn="l" defTabSz="914400" rtl="0" eaLnBrk="1" latinLnBrk="0" hangingPunct="1">
       <a:defRPr sz="1200" kern="1200">
         <a:solidFill>
           <a:schemeClr val="tx1"/>
@@ -792,7 +692,7 @@
         <a:cs typeface="+mn-cs"/>
       </a:defRPr>
     </a:lvl4pPr>
-    <a:lvl5pPr marL="1828800" algn="l" defTabSz="457200" rtl="0" eaLnBrk="1" latinLnBrk="0" hangingPunct="1">
+    <a:lvl5pPr marL="1828800" algn="l" defTabSz="914400" rtl="0" eaLnBrk="1" latinLnBrk="0" hangingPunct="1">
       <a:defRPr sz="1200" kern="1200">
         <a:solidFill>
           <a:schemeClr val="tx1"/>
@@ -802,7 +702,7 @@
         <a:cs typeface="+mn-cs"/>
       </a:defRPr>
     </a:lvl5pPr>
-    <a:lvl6pPr marL="2286000" algn="l" defTabSz="457200" rtl="0" eaLnBrk="1" latinLnBrk="0" hangingPunct="1">
+    <a:lvl6pPr marL="2286000" algn="l" defTabSz="914400" rtl="0" eaLnBrk="1" latinLnBrk="0" hangingPunct="1">
       <a:defRPr sz="1200" kern="1200">
         <a:solidFill>
           <a:schemeClr val="tx1"/>
@@ -812,7 +712,7 @@
         <a:cs typeface="+mn-cs"/>
       </a:defRPr>
     </a:lvl6pPr>
-    <a:lvl7pPr marL="2743200" algn="l" defTabSz="457200" rtl="0" eaLnBrk="1" latinLnBrk="0" hangingPunct="1">
+    <a:lvl7pPr marL="2743200" algn="l" defTabSz="914400" rtl="0" eaLnBrk="1" latinLnBrk="0" hangingPunct="1">
       <a:defRPr sz="1200" kern="1200">
         <a:solidFill>
           <a:schemeClr val="tx1"/>
@@ -822,7 +722,7 @@
         <a:cs typeface="+mn-cs"/>
       </a:defRPr>
     </a:lvl7pPr>
-    <a:lvl8pPr marL="3200400" algn="l" defTabSz="457200" rtl="0" eaLnBrk="1" latinLnBrk="0" hangingPunct="1">
+    <a:lvl8pPr marL="3200400" algn="l" defTabSz="914400" rtl="0" eaLnBrk="1" latinLnBrk="0" hangingPunct="1">
       <a:defRPr sz="1200" kern="1200">
         <a:solidFill>
           <a:schemeClr val="tx1"/>
@@ -832,7 +732,7 @@
         <a:cs typeface="+mn-cs"/>
       </a:defRPr>
     </a:lvl8pPr>
-    <a:lvl9pPr marL="3657600" algn="l" defTabSz="457200" rtl="0" eaLnBrk="1" latinLnBrk="0" hangingPunct="1">
+    <a:lvl9pPr marL="3657600" algn="l" defTabSz="914400" rtl="0" eaLnBrk="1" latinLnBrk="0" hangingPunct="1">
       <a:defRPr sz="1200" kern="1200">
         <a:solidFill>
           <a:schemeClr val="tx1"/>
@@ -847,7 +747,7 @@
 </file>
 
 <file path=ppt/notesSlides/notesSlide1.xml><?xml version="1.0" encoding="utf-8"?>
-<p:notes xmlns:a="http://schemas.openxmlformats.org/drawingml/2006/main" xmlns:p="http://schemas.openxmlformats.org/presentationml/2006/main" xmlns:r="http://schemas.openxmlformats.org/officeDocument/2006/relationships">
+<p:notes xmlns:a="http://schemas.openxmlformats.org/drawingml/2006/main" xmlns:r="http://schemas.openxmlformats.org/officeDocument/2006/relationships" xmlns:p="http://schemas.openxmlformats.org/presentationml/2006/main">
   <p:cSld>
     <p:spTree>
       <p:nvGrpSpPr>
@@ -867,7 +767,7 @@
         <p:nvSpPr>
           <p:cNvPr id="2" name="Slide Image Placeholder 1"/>
           <p:cNvSpPr>
-            <a:spLocks noGrp="1"/>
+            <a:spLocks noGrp="1" noRot="1" noChangeAspect="1"/>
           </p:cNvSpPr>
           <p:nvPr>
             <p:ph type="sldImg" idx="2"/>
@@ -882,7 +782,7 @@
             <a:spLocks noGrp="1"/>
           </p:cNvSpPr>
           <p:nvPr>
-            <p:ph type="body" idx="3" sz="quarter"/>
+            <p:ph type="body" sz="quarter" idx="3"/>
           </p:nvPr>
         </p:nvSpPr>
         <p:spPr/>
@@ -903,7 +803,7 @@
             <a:spLocks noGrp="1"/>
           </p:cNvSpPr>
           <p:nvPr>
-            <p:ph type="sldNum" idx="5" sz="quarter"/>
+            <p:ph type="sldNum" sz="quarter" idx="5"/>
           </p:nvPr>
         </p:nvSpPr>
         <p:spPr/>
@@ -917,7 +817,7 @@
 </file>
 
 <file path=ppt/notesSlides/notesSlide10.xml><?xml version="1.0" encoding="utf-8"?>
-<p:notes xmlns:a="http://schemas.openxmlformats.org/drawingml/2006/main" xmlns:p="http://schemas.openxmlformats.org/presentationml/2006/main" xmlns:r="http://schemas.openxmlformats.org/officeDocument/2006/relationships">
+<p:notes xmlns:a="http://schemas.openxmlformats.org/drawingml/2006/main" xmlns:r="http://schemas.openxmlformats.org/officeDocument/2006/relationships" xmlns:p="http://schemas.openxmlformats.org/presentationml/2006/main">
   <p:cSld>
     <p:spTree>
       <p:nvGrpSpPr>
@@ -937,7 +837,7 @@
         <p:nvSpPr>
           <p:cNvPr id="2" name="Slide Image Placeholder 1"/>
           <p:cNvSpPr>
-            <a:spLocks noGrp="1"/>
+            <a:spLocks noGrp="1" noRot="1" noChangeAspect="1"/>
           </p:cNvSpPr>
           <p:nvPr>
             <p:ph type="sldImg" idx="2"/>
@@ -952,7 +852,7 @@
             <a:spLocks noGrp="1"/>
           </p:cNvSpPr>
           <p:nvPr>
-            <p:ph type="body" idx="3" sz="quarter"/>
+            <p:ph type="body" sz="quarter" idx="3"/>
           </p:nvPr>
         </p:nvSpPr>
         <p:spPr/>
@@ -973,7 +873,7 @@
             <a:spLocks noGrp="1"/>
           </p:cNvSpPr>
           <p:nvPr>
-            <p:ph type="sldNum" idx="5" sz="quarter"/>
+            <p:ph type="sldNum" sz="quarter" idx="5"/>
           </p:nvPr>
         </p:nvSpPr>
         <p:spPr/>
@@ -987,7 +887,7 @@
 </file>
 
 <file path=ppt/notesSlides/notesSlide2.xml><?xml version="1.0" encoding="utf-8"?>
-<p:notes xmlns:a="http://schemas.openxmlformats.org/drawingml/2006/main" xmlns:p="http://schemas.openxmlformats.org/presentationml/2006/main" xmlns:r="http://schemas.openxmlformats.org/officeDocument/2006/relationships">
+<p:notes xmlns:a="http://schemas.openxmlformats.org/drawingml/2006/main" xmlns:r="http://schemas.openxmlformats.org/officeDocument/2006/relationships" xmlns:p="http://schemas.openxmlformats.org/presentationml/2006/main">
   <p:cSld>
     <p:spTree>
       <p:nvGrpSpPr>
@@ -1007,7 +907,7 @@
         <p:nvSpPr>
           <p:cNvPr id="2" name="Slide Image Placeholder 1"/>
           <p:cNvSpPr>
-            <a:spLocks noGrp="1"/>
+            <a:spLocks noGrp="1" noRot="1" noChangeAspect="1"/>
           </p:cNvSpPr>
           <p:nvPr>
             <p:ph type="sldImg" idx="2"/>
@@ -1022,7 +922,7 @@
             <a:spLocks noGrp="1"/>
           </p:cNvSpPr>
           <p:nvPr>
-            <p:ph type="body" idx="3" sz="quarter"/>
+            <p:ph type="body" sz="quarter" idx="3"/>
           </p:nvPr>
         </p:nvSpPr>
         <p:spPr/>
@@ -1043,7 +943,7 @@
             <a:spLocks noGrp="1"/>
           </p:cNvSpPr>
           <p:nvPr>
-            <p:ph type="sldNum" idx="5" sz="quarter"/>
+            <p:ph type="sldNum" sz="quarter" idx="5"/>
           </p:nvPr>
         </p:nvSpPr>
         <p:spPr/>
@@ -1057,7 +957,7 @@
 </file>
 
 <file path=ppt/notesSlides/notesSlide3.xml><?xml version="1.0" encoding="utf-8"?>
-<p:notes xmlns:a="http://schemas.openxmlformats.org/drawingml/2006/main" xmlns:p="http://schemas.openxmlformats.org/presentationml/2006/main" xmlns:r="http://schemas.openxmlformats.org/officeDocument/2006/relationships">
+<p:notes xmlns:a="http://schemas.openxmlformats.org/drawingml/2006/main" xmlns:r="http://schemas.openxmlformats.org/officeDocument/2006/relationships" xmlns:p="http://schemas.openxmlformats.org/presentationml/2006/main">
   <p:cSld>
     <p:spTree>
       <p:nvGrpSpPr>
@@ -1077,7 +977,7 @@
         <p:nvSpPr>
           <p:cNvPr id="2" name="Slide Image Placeholder 1"/>
           <p:cNvSpPr>
-            <a:spLocks noGrp="1"/>
+            <a:spLocks noGrp="1" noRot="1" noChangeAspect="1"/>
           </p:cNvSpPr>
           <p:nvPr>
             <p:ph type="sldImg" idx="2"/>
@@ -1092,7 +992,7 @@
             <a:spLocks noGrp="1"/>
           </p:cNvSpPr>
           <p:nvPr>
-            <p:ph type="body" idx="3" sz="quarter"/>
+            <p:ph type="body" sz="quarter" idx="3"/>
           </p:nvPr>
         </p:nvSpPr>
         <p:spPr/>
@@ -1113,7 +1013,7 @@
             <a:spLocks noGrp="1"/>
           </p:cNvSpPr>
           <p:nvPr>
-            <p:ph type="sldNum" idx="5" sz="quarter"/>
+            <p:ph type="sldNum" sz="quarter" idx="5"/>
           </p:nvPr>
         </p:nvSpPr>
         <p:spPr/>
@@ -1127,7 +1027,7 @@
 </file>
 
 <file path=ppt/notesSlides/notesSlide4.xml><?xml version="1.0" encoding="utf-8"?>
-<p:notes xmlns:a="http://schemas.openxmlformats.org/drawingml/2006/main" xmlns:p="http://schemas.openxmlformats.org/presentationml/2006/main" xmlns:r="http://schemas.openxmlformats.org/officeDocument/2006/relationships">
+<p:notes xmlns:a="http://schemas.openxmlformats.org/drawingml/2006/main" xmlns:r="http://schemas.openxmlformats.org/officeDocument/2006/relationships" xmlns:p="http://schemas.openxmlformats.org/presentationml/2006/main">
   <p:cSld>
     <p:spTree>
       <p:nvGrpSpPr>
@@ -1147,7 +1047,7 @@
         <p:nvSpPr>
           <p:cNvPr id="2" name="Slide Image Placeholder 1"/>
           <p:cNvSpPr>
-            <a:spLocks noGrp="1"/>
+            <a:spLocks noGrp="1" noRot="1" noChangeAspect="1"/>
           </p:cNvSpPr>
           <p:nvPr>
             <p:ph type="sldImg" idx="2"/>
@@ -1162,7 +1062,7 @@
             <a:spLocks noGrp="1"/>
           </p:cNvSpPr>
           <p:nvPr>
-            <p:ph type="body" idx="3" sz="quarter"/>
+            <p:ph type="body" sz="quarter" idx="3"/>
           </p:nvPr>
         </p:nvSpPr>
         <p:spPr/>
@@ -1183,7 +1083,7 @@
             <a:spLocks noGrp="1"/>
           </p:cNvSpPr>
           <p:nvPr>
-            <p:ph type="sldNum" idx="5" sz="quarter"/>
+            <p:ph type="sldNum" sz="quarter" idx="5"/>
           </p:nvPr>
         </p:nvSpPr>
         <p:spPr/>
@@ -1197,7 +1097,7 @@
 </file>
 
 <file path=ppt/notesSlides/notesSlide5.xml><?xml version="1.0" encoding="utf-8"?>
-<p:notes xmlns:a="http://schemas.openxmlformats.org/drawingml/2006/main" xmlns:p="http://schemas.openxmlformats.org/presentationml/2006/main" xmlns:r="http://schemas.openxmlformats.org/officeDocument/2006/relationships">
+<p:notes xmlns:a="http://schemas.openxmlformats.org/drawingml/2006/main" xmlns:r="http://schemas.openxmlformats.org/officeDocument/2006/relationships" xmlns:p="http://schemas.openxmlformats.org/presentationml/2006/main">
   <p:cSld>
     <p:spTree>
       <p:nvGrpSpPr>
@@ -1217,7 +1117,7 @@
         <p:nvSpPr>
           <p:cNvPr id="2" name="Slide Image Placeholder 1"/>
           <p:cNvSpPr>
-            <a:spLocks noGrp="1"/>
+            <a:spLocks noGrp="1" noRot="1" noChangeAspect="1"/>
           </p:cNvSpPr>
           <p:nvPr>
             <p:ph type="sldImg" idx="2"/>
@@ -1232,7 +1132,7 @@
             <a:spLocks noGrp="1"/>
           </p:cNvSpPr>
           <p:nvPr>
-            <p:ph type="body" idx="3" sz="quarter"/>
+            <p:ph type="body" sz="quarter" idx="3"/>
           </p:nvPr>
         </p:nvSpPr>
         <p:spPr/>
@@ -1253,7 +1153,7 @@
             <a:spLocks noGrp="1"/>
           </p:cNvSpPr>
           <p:nvPr>
-            <p:ph type="sldNum" idx="5" sz="quarter"/>
+            <p:ph type="sldNum" sz="quarter" idx="5"/>
           </p:nvPr>
         </p:nvSpPr>
         <p:spPr/>
@@ -1267,7 +1167,7 @@
 </file>
 
 <file path=ppt/notesSlides/notesSlide6.xml><?xml version="1.0" encoding="utf-8"?>
-<p:notes xmlns:a="http://schemas.openxmlformats.org/drawingml/2006/main" xmlns:p="http://schemas.openxmlformats.org/presentationml/2006/main" xmlns:r="http://schemas.openxmlformats.org/officeDocument/2006/relationships">
+<p:notes xmlns:a="http://schemas.openxmlformats.org/drawingml/2006/main" xmlns:r="http://schemas.openxmlformats.org/officeDocument/2006/relationships" xmlns:p="http://schemas.openxmlformats.org/presentationml/2006/main">
   <p:cSld>
     <p:spTree>
       <p:nvGrpSpPr>
@@ -1287,7 +1187,7 @@
         <p:nvSpPr>
           <p:cNvPr id="2" name="Slide Image Placeholder 1"/>
           <p:cNvSpPr>
-            <a:spLocks noGrp="1"/>
+            <a:spLocks noGrp="1" noRot="1" noChangeAspect="1"/>
           </p:cNvSpPr>
           <p:nvPr>
             <p:ph type="sldImg" idx="2"/>
@@ -1302,7 +1202,7 @@
             <a:spLocks noGrp="1"/>
           </p:cNvSpPr>
           <p:nvPr>
-            <p:ph type="body" idx="3" sz="quarter"/>
+            <p:ph type="body" sz="quarter" idx="3"/>
           </p:nvPr>
         </p:nvSpPr>
         <p:spPr/>
@@ -1323,7 +1223,7 @@
             <a:spLocks noGrp="1"/>
           </p:cNvSpPr>
           <p:nvPr>
-            <p:ph type="sldNum" idx="5" sz="quarter"/>
+            <p:ph type="sldNum" sz="quarter" idx="5"/>
           </p:nvPr>
         </p:nvSpPr>
         <p:spPr/>
@@ -1337,7 +1237,7 @@
 </file>
 
 <file path=ppt/notesSlides/notesSlide7.xml><?xml version="1.0" encoding="utf-8"?>
-<p:notes xmlns:a="http://schemas.openxmlformats.org/drawingml/2006/main" xmlns:p="http://schemas.openxmlformats.org/presentationml/2006/main" xmlns:r="http://schemas.openxmlformats.org/officeDocument/2006/relationships">
+<p:notes xmlns:a="http://schemas.openxmlformats.org/drawingml/2006/main" xmlns:r="http://schemas.openxmlformats.org/officeDocument/2006/relationships" xmlns:p="http://schemas.openxmlformats.org/presentationml/2006/main">
   <p:cSld>
     <p:spTree>
       <p:nvGrpSpPr>
@@ -1357,7 +1257,7 @@
         <p:nvSpPr>
           <p:cNvPr id="2" name="Slide Image Placeholder 1"/>
           <p:cNvSpPr>
-            <a:spLocks noGrp="1"/>
+            <a:spLocks noGrp="1" noRot="1" noChangeAspect="1"/>
           </p:cNvSpPr>
           <p:nvPr>
             <p:ph type="sldImg" idx="2"/>
@@ -1372,7 +1272,7 @@
             <a:spLocks noGrp="1"/>
           </p:cNvSpPr>
           <p:nvPr>
-            <p:ph type="body" idx="3" sz="quarter"/>
+            <p:ph type="body" sz="quarter" idx="3"/>
           </p:nvPr>
         </p:nvSpPr>
         <p:spPr/>
@@ -1393,7 +1293,7 @@
             <a:spLocks noGrp="1"/>
           </p:cNvSpPr>
           <p:nvPr>
-            <p:ph type="sldNum" idx="5" sz="quarter"/>
+            <p:ph type="sldNum" sz="quarter" idx="5"/>
           </p:nvPr>
         </p:nvSpPr>
         <p:spPr/>
@@ -1407,7 +1307,7 @@
 </file>
 
 <file path=ppt/notesSlides/notesSlide8.xml><?xml version="1.0" encoding="utf-8"?>
-<p:notes xmlns:a="http://schemas.openxmlformats.org/drawingml/2006/main" xmlns:p="http://schemas.openxmlformats.org/presentationml/2006/main" xmlns:r="http://schemas.openxmlformats.org/officeDocument/2006/relationships">
+<p:notes xmlns:a="http://schemas.openxmlformats.org/drawingml/2006/main" xmlns:r="http://schemas.openxmlformats.org/officeDocument/2006/relationships" xmlns:p="http://schemas.openxmlformats.org/presentationml/2006/main">
   <p:cSld>
     <p:spTree>
       <p:nvGrpSpPr>
@@ -1427,7 +1327,7 @@
         <p:nvSpPr>
           <p:cNvPr id="2" name="Slide Image Placeholder 1"/>
           <p:cNvSpPr>
-            <a:spLocks noGrp="1"/>
+            <a:spLocks noGrp="1" noRot="1" noChangeAspect="1"/>
           </p:cNvSpPr>
           <p:nvPr>
             <p:ph type="sldImg" idx="2"/>
@@ -1442,7 +1342,7 @@
             <a:spLocks noGrp="1"/>
           </p:cNvSpPr>
           <p:nvPr>
-            <p:ph type="body" idx="3" sz="quarter"/>
+            <p:ph type="body" sz="quarter" idx="3"/>
           </p:nvPr>
         </p:nvSpPr>
         <p:spPr/>
@@ -1463,7 +1363,7 @@
             <a:spLocks noGrp="1"/>
           </p:cNvSpPr>
           <p:nvPr>
-            <p:ph type="sldNum" idx="5" sz="quarter"/>
+            <p:ph type="sldNum" sz="quarter" idx="5"/>
           </p:nvPr>
         </p:nvSpPr>
         <p:spPr/>
@@ -1477,7 +1377,7 @@
 </file>
 
 <file path=ppt/notesSlides/notesSlide9.xml><?xml version="1.0" encoding="utf-8"?>
-<p:notes xmlns:a="http://schemas.openxmlformats.org/drawingml/2006/main" xmlns:p="http://schemas.openxmlformats.org/presentationml/2006/main" xmlns:r="http://schemas.openxmlformats.org/officeDocument/2006/relationships">
+<p:notes xmlns:a="http://schemas.openxmlformats.org/drawingml/2006/main" xmlns:r="http://schemas.openxmlformats.org/officeDocument/2006/relationships" xmlns:p="http://schemas.openxmlformats.org/presentationml/2006/main">
   <p:cSld>
     <p:spTree>
       <p:nvGrpSpPr>
@@ -1497,7 +1397,7 @@
         <p:nvSpPr>
           <p:cNvPr id="2" name="Slide Image Placeholder 1"/>
           <p:cNvSpPr>
-            <a:spLocks noGrp="1"/>
+            <a:spLocks noGrp="1" noRot="1" noChangeAspect="1"/>
           </p:cNvSpPr>
           <p:nvPr>
             <p:ph type="sldImg" idx="2"/>
@@ -1512,7 +1412,7 @@
             <a:spLocks noGrp="1"/>
           </p:cNvSpPr>
           <p:nvPr>
-            <p:ph type="body" idx="3" sz="quarter"/>
+            <p:ph type="body" sz="quarter" idx="3"/>
           </p:nvPr>
         </p:nvSpPr>
         <p:spPr/>
@@ -1533,7 +1433,7 @@
             <a:spLocks noGrp="1"/>
           </p:cNvSpPr>
           <p:nvPr>
-            <p:ph type="sldNum" idx="5" sz="quarter"/>
+            <p:ph type="sldNum" sz="quarter" idx="5"/>
           </p:nvPr>
         </p:nvSpPr>
         <p:spPr/>
@@ -1584,10 +1484,9 @@
           <a:lstStyle/>
           <a:p>
             <a:r>
-              <a:rPr lang="en-US" smtClean="0"/>
+              <a:rPr lang="en-US"/>
               <a:t>Click to edit Master title style</a:t>
             </a:r>
-            <a:endParaRPr lang="en-US"/>
           </a:p>
         </p:txBody>
       </p:sp>
@@ -1703,10 +1602,9 @@
           </a:lstStyle>
           <a:p>
             <a:r>
-              <a:rPr lang="en-US" smtClean="0"/>
+              <a:rPr lang="en-US"/>
               <a:t>Click to edit Master subtitle style</a:t>
             </a:r>
-            <a:endParaRPr lang="en-US"/>
           </a:p>
         </p:txBody>
       </p:sp>
@@ -1727,7 +1625,7 @@
           <a:p>
             <a:fld id="{5BCAD085-E8A6-8845-BD4E-CB4CCA059FC4}" type="datetimeFigureOut">
               <a:rPr lang="en-US" smtClean="0"/>
-              <a:t>1/27/13</a:t>
+              <a:t>10/3/26</a:t>
             </a:fld>
             <a:endParaRPr lang="en-US"/>
           </a:p>
@@ -1821,10 +1719,9 @@
           <a:lstStyle/>
           <a:p>
             <a:r>
-              <a:rPr lang="en-US" smtClean="0"/>
+              <a:rPr lang="en-US"/>
               <a:t>Click to edit Master title style</a:t>
             </a:r>
-            <a:endParaRPr lang="en-US"/>
           </a:p>
         </p:txBody>
       </p:sp>
@@ -1845,38 +1742,37 @@
           <a:p>
             <a:pPr lvl="0"/>
             <a:r>
-              <a:rPr lang="en-US" smtClean="0"/>
+              <a:rPr lang="en-US"/>
               <a:t>Click to edit Master text styles</a:t>
             </a:r>
           </a:p>
           <a:p>
             <a:pPr lvl="1"/>
             <a:r>
-              <a:rPr lang="en-US" smtClean="0"/>
+              <a:rPr lang="en-US"/>
               <a:t>Second level</a:t>
             </a:r>
           </a:p>
           <a:p>
             <a:pPr lvl="2"/>
             <a:r>
-              <a:rPr lang="en-US" smtClean="0"/>
+              <a:rPr lang="en-US"/>
               <a:t>Third level</a:t>
             </a:r>
           </a:p>
           <a:p>
             <a:pPr lvl="3"/>
             <a:r>
-              <a:rPr lang="en-US" smtClean="0"/>
+              <a:rPr lang="en-US"/>
               <a:t>Fourth level</a:t>
             </a:r>
           </a:p>
           <a:p>
             <a:pPr lvl="4"/>
             <a:r>
-              <a:rPr lang="en-US" smtClean="0"/>
+              <a:rPr lang="en-US"/>
               <a:t>Fifth level</a:t>
             </a:r>
-            <a:endParaRPr lang="en-US"/>
           </a:p>
         </p:txBody>
       </p:sp>
@@ -1897,7 +1793,7 @@
           <a:p>
             <a:fld id="{5BCAD085-E8A6-8845-BD4E-CB4CCA059FC4}" type="datetimeFigureOut">
               <a:rPr lang="en-US" smtClean="0"/>
-              <a:t>1/27/13</a:t>
+              <a:t>10/3/26</a:t>
             </a:fld>
             <a:endParaRPr lang="en-US"/>
           </a:p>
@@ -1996,10 +1892,9 @@
           <a:lstStyle/>
           <a:p>
             <a:r>
-              <a:rPr lang="en-US" smtClean="0"/>
+              <a:rPr lang="en-US"/>
               <a:t>Click to edit Master title style</a:t>
             </a:r>
-            <a:endParaRPr lang="en-US"/>
           </a:p>
         </p:txBody>
       </p:sp>
@@ -2025,38 +1920,37 @@
           <a:p>
             <a:pPr lvl="0"/>
             <a:r>
-              <a:rPr lang="en-US" smtClean="0"/>
+              <a:rPr lang="en-US"/>
               <a:t>Click to edit Master text styles</a:t>
             </a:r>
           </a:p>
           <a:p>
             <a:pPr lvl="1"/>
             <a:r>
-              <a:rPr lang="en-US" smtClean="0"/>
+              <a:rPr lang="en-US"/>
               <a:t>Second level</a:t>
             </a:r>
           </a:p>
           <a:p>
             <a:pPr lvl="2"/>
             <a:r>
-              <a:rPr lang="en-US" smtClean="0"/>
+              <a:rPr lang="en-US"/>
               <a:t>Third level</a:t>
             </a:r>
           </a:p>
           <a:p>
             <a:pPr lvl="3"/>
             <a:r>
-              <a:rPr lang="en-US" smtClean="0"/>
+              <a:rPr lang="en-US"/>
               <a:t>Fourth level</a:t>
             </a:r>
           </a:p>
           <a:p>
             <a:pPr lvl="4"/>
             <a:r>
-              <a:rPr lang="en-US" smtClean="0"/>
+              <a:rPr lang="en-US"/>
               <a:t>Fifth level</a:t>
             </a:r>
-            <a:endParaRPr lang="en-US"/>
           </a:p>
         </p:txBody>
       </p:sp>
@@ -2077,7 +1971,7 @@
           <a:p>
             <a:fld id="{5BCAD085-E8A6-8845-BD4E-CB4CCA059FC4}" type="datetimeFigureOut">
               <a:rPr lang="en-US" smtClean="0"/>
-              <a:t>1/27/13</a:t>
+              <a:t>10/3/26</a:t>
             </a:fld>
             <a:endParaRPr lang="en-US"/>
           </a:p>
@@ -2171,10 +2065,9 @@
           <a:lstStyle/>
           <a:p>
             <a:r>
-              <a:rPr lang="en-US" smtClean="0"/>
+              <a:rPr lang="en-US"/>
               <a:t>Click to edit Master title style</a:t>
             </a:r>
-            <a:endParaRPr lang="en-US"/>
           </a:p>
         </p:txBody>
       </p:sp>
@@ -2195,38 +2088,37 @@
           <a:p>
             <a:pPr lvl="0"/>
             <a:r>
-              <a:rPr lang="en-US" smtClean="0"/>
+              <a:rPr lang="en-US"/>
               <a:t>Click to edit Master text styles</a:t>
             </a:r>
           </a:p>
           <a:p>
             <a:pPr lvl="1"/>
             <a:r>
-              <a:rPr lang="en-US" smtClean="0"/>
+              <a:rPr lang="en-US"/>
               <a:t>Second level</a:t>
             </a:r>
           </a:p>
           <a:p>
             <a:pPr lvl="2"/>
             <a:r>
-              <a:rPr lang="en-US" smtClean="0"/>
+              <a:rPr lang="en-US"/>
               <a:t>Third level</a:t>
             </a:r>
           </a:p>
           <a:p>
             <a:pPr lvl="3"/>
             <a:r>
-              <a:rPr lang="en-US" smtClean="0"/>
+              <a:rPr lang="en-US"/>
               <a:t>Fourth level</a:t>
             </a:r>
           </a:p>
           <a:p>
             <a:pPr lvl="4"/>
             <a:r>
-              <a:rPr lang="en-US" smtClean="0"/>
+              <a:rPr lang="en-US"/>
               <a:t>Fifth level</a:t>
             </a:r>
-            <a:endParaRPr lang="en-US"/>
           </a:p>
         </p:txBody>
       </p:sp>
@@ -2247,7 +2139,7 @@
           <a:p>
             <a:fld id="{5BCAD085-E8A6-8845-BD4E-CB4CCA059FC4}" type="datetimeFigureOut">
               <a:rPr lang="en-US" smtClean="0"/>
-              <a:t>1/27/13</a:t>
+              <a:t>10/3/26</a:t>
             </a:fld>
             <a:endParaRPr lang="en-US"/>
           </a:p>
@@ -2350,10 +2242,9 @@
           </a:lstStyle>
           <a:p>
             <a:r>
-              <a:rPr lang="en-US" smtClean="0"/>
+              <a:rPr lang="en-US"/>
               <a:t>Click to edit Master title style</a:t>
             </a:r>
-            <a:endParaRPr lang="en-US"/>
           </a:p>
         </p:txBody>
       </p:sp>
@@ -2470,7 +2361,7 @@
           <a:p>
             <a:pPr lvl="0"/>
             <a:r>
-              <a:rPr lang="en-US" smtClean="0"/>
+              <a:rPr lang="en-US"/>
               <a:t>Click to edit Master text styles</a:t>
             </a:r>
           </a:p>
@@ -2493,7 +2384,7 @@
           <a:p>
             <a:fld id="{5BCAD085-E8A6-8845-BD4E-CB4CCA059FC4}" type="datetimeFigureOut">
               <a:rPr lang="en-US" smtClean="0"/>
-              <a:t>1/27/13</a:t>
+              <a:t>10/3/26</a:t>
             </a:fld>
             <a:endParaRPr lang="en-US"/>
           </a:p>
@@ -2587,10 +2478,9 @@
           <a:lstStyle/>
           <a:p>
             <a:r>
-              <a:rPr lang="en-US" smtClean="0"/>
+              <a:rPr lang="en-US"/>
               <a:t>Click to edit Master title style</a:t>
             </a:r>
-            <a:endParaRPr lang="en-US"/>
           </a:p>
         </p:txBody>
       </p:sp>
@@ -2644,38 +2534,37 @@
           <a:p>
             <a:pPr lvl="0"/>
             <a:r>
-              <a:rPr lang="en-US" smtClean="0"/>
+              <a:rPr lang="en-US"/>
               <a:t>Click to edit Master text styles</a:t>
             </a:r>
           </a:p>
           <a:p>
             <a:pPr lvl="1"/>
             <a:r>
-              <a:rPr lang="en-US" smtClean="0"/>
+              <a:rPr lang="en-US"/>
               <a:t>Second level</a:t>
             </a:r>
           </a:p>
           <a:p>
             <a:pPr lvl="2"/>
             <a:r>
-              <a:rPr lang="en-US" smtClean="0"/>
+              <a:rPr lang="en-US"/>
               <a:t>Third level</a:t>
             </a:r>
           </a:p>
           <a:p>
             <a:pPr lvl="3"/>
             <a:r>
-              <a:rPr lang="en-US" smtClean="0"/>
+              <a:rPr lang="en-US"/>
               <a:t>Fourth level</a:t>
             </a:r>
           </a:p>
           <a:p>
             <a:pPr lvl="4"/>
             <a:r>
-              <a:rPr lang="en-US" smtClean="0"/>
+              <a:rPr lang="en-US"/>
               <a:t>Fifth level</a:t>
             </a:r>
-            <a:endParaRPr lang="en-US"/>
           </a:p>
         </p:txBody>
       </p:sp>
@@ -2729,38 +2618,37 @@
           <a:p>
             <a:pPr lvl="0"/>
             <a:r>
-              <a:rPr lang="en-US" smtClean="0"/>
+              <a:rPr lang="en-US"/>
               <a:t>Click to edit Master text styles</a:t>
             </a:r>
           </a:p>
           <a:p>
             <a:pPr lvl="1"/>
             <a:r>
-              <a:rPr lang="en-US" smtClean="0"/>
+              <a:rPr lang="en-US"/>
               <a:t>Second level</a:t>
             </a:r>
           </a:p>
           <a:p>
             <a:pPr lvl="2"/>
             <a:r>
-              <a:rPr lang="en-US" smtClean="0"/>
+              <a:rPr lang="en-US"/>
               <a:t>Third level</a:t>
             </a:r>
           </a:p>
           <a:p>
             <a:pPr lvl="3"/>
             <a:r>
-              <a:rPr lang="en-US" smtClean="0"/>
+              <a:rPr lang="en-US"/>
               <a:t>Fourth level</a:t>
             </a:r>
           </a:p>
           <a:p>
             <a:pPr lvl="4"/>
             <a:r>
-              <a:rPr lang="en-US" smtClean="0"/>
+              <a:rPr lang="en-US"/>
               <a:t>Fifth level</a:t>
             </a:r>
-            <a:endParaRPr lang="en-US"/>
           </a:p>
         </p:txBody>
       </p:sp>
@@ -2781,7 +2669,7 @@
           <a:p>
             <a:fld id="{5BCAD085-E8A6-8845-BD4E-CB4CCA059FC4}" type="datetimeFigureOut">
               <a:rPr lang="en-US" smtClean="0"/>
-              <a:t>1/27/13</a:t>
+              <a:t>10/3/26</a:t>
             </a:fld>
             <a:endParaRPr lang="en-US"/>
           </a:p>
@@ -2879,10 +2767,9 @@
           </a:lstStyle>
           <a:p>
             <a:r>
-              <a:rPr lang="en-US" smtClean="0"/>
+              <a:rPr lang="en-US"/>
               <a:t>Click to edit Master title style</a:t>
             </a:r>
-            <a:endParaRPr lang="en-US"/>
           </a:p>
         </p:txBody>
       </p:sp>
@@ -2945,7 +2832,7 @@
           <a:p>
             <a:pPr lvl="0"/>
             <a:r>
-              <a:rPr lang="en-US" smtClean="0"/>
+              <a:rPr lang="en-US"/>
               <a:t>Click to edit Master text styles</a:t>
             </a:r>
           </a:p>
@@ -3001,38 +2888,37 @@
           <a:p>
             <a:pPr lvl="0"/>
             <a:r>
-              <a:rPr lang="en-US" smtClean="0"/>
+              <a:rPr lang="en-US"/>
               <a:t>Click to edit Master text styles</a:t>
             </a:r>
           </a:p>
           <a:p>
             <a:pPr lvl="1"/>
             <a:r>
-              <a:rPr lang="en-US" smtClean="0"/>
+              <a:rPr lang="en-US"/>
               <a:t>Second level</a:t>
             </a:r>
           </a:p>
           <a:p>
             <a:pPr lvl="2"/>
             <a:r>
-              <a:rPr lang="en-US" smtClean="0"/>
+              <a:rPr lang="en-US"/>
               <a:t>Third level</a:t>
             </a:r>
           </a:p>
           <a:p>
             <a:pPr lvl="3"/>
             <a:r>
-              <a:rPr lang="en-US" smtClean="0"/>
+              <a:rPr lang="en-US"/>
               <a:t>Fourth level</a:t>
             </a:r>
           </a:p>
           <a:p>
             <a:pPr lvl="4"/>
             <a:r>
-              <a:rPr lang="en-US" smtClean="0"/>
+              <a:rPr lang="en-US"/>
               <a:t>Fifth level</a:t>
             </a:r>
-            <a:endParaRPr lang="en-US"/>
           </a:p>
         </p:txBody>
       </p:sp>
@@ -3095,7 +2981,7 @@
           <a:p>
             <a:pPr lvl="0"/>
             <a:r>
-              <a:rPr lang="en-US" smtClean="0"/>
+              <a:rPr lang="en-US"/>
               <a:t>Click to edit Master text styles</a:t>
             </a:r>
           </a:p>
@@ -3151,38 +3037,37 @@
           <a:p>
             <a:pPr lvl="0"/>
             <a:r>
-              <a:rPr lang="en-US" smtClean="0"/>
+              <a:rPr lang="en-US"/>
               <a:t>Click to edit Master text styles</a:t>
             </a:r>
           </a:p>
           <a:p>
             <a:pPr lvl="1"/>
             <a:r>
-              <a:rPr lang="en-US" smtClean="0"/>
+              <a:rPr lang="en-US"/>
               <a:t>Second level</a:t>
             </a:r>
           </a:p>
           <a:p>
             <a:pPr lvl="2"/>
             <a:r>
-              <a:rPr lang="en-US" smtClean="0"/>
+              <a:rPr lang="en-US"/>
               <a:t>Third level</a:t>
             </a:r>
           </a:p>
           <a:p>
             <a:pPr lvl="3"/>
             <a:r>
-              <a:rPr lang="en-US" smtClean="0"/>
+              <a:rPr lang="en-US"/>
               <a:t>Fourth level</a:t>
             </a:r>
           </a:p>
           <a:p>
             <a:pPr lvl="4"/>
             <a:r>
-              <a:rPr lang="en-US" smtClean="0"/>
+              <a:rPr lang="en-US"/>
               <a:t>Fifth level</a:t>
             </a:r>
-            <a:endParaRPr lang="en-US"/>
           </a:p>
         </p:txBody>
       </p:sp>
@@ -3203,7 +3088,7 @@
           <a:p>
             <a:fld id="{5BCAD085-E8A6-8845-BD4E-CB4CCA059FC4}" type="datetimeFigureOut">
               <a:rPr lang="en-US" smtClean="0"/>
-              <a:t>1/27/13</a:t>
+              <a:t>10/3/26</a:t>
             </a:fld>
             <a:endParaRPr lang="en-US"/>
           </a:p>
@@ -3297,10 +3182,9 @@
           <a:lstStyle/>
           <a:p>
             <a:r>
-              <a:rPr lang="en-US" smtClean="0"/>
+              <a:rPr lang="en-US"/>
               <a:t>Click to edit Master title style</a:t>
             </a:r>
-            <a:endParaRPr lang="en-US"/>
           </a:p>
         </p:txBody>
       </p:sp>
@@ -3321,7 +3205,7 @@
           <a:p>
             <a:fld id="{5BCAD085-E8A6-8845-BD4E-CB4CCA059FC4}" type="datetimeFigureOut">
               <a:rPr lang="en-US" smtClean="0"/>
-              <a:t>1/27/13</a:t>
+              <a:t>10/3/26</a:t>
             </a:fld>
             <a:endParaRPr lang="en-US"/>
           </a:p>
@@ -3416,7 +3300,7 @@
           <a:p>
             <a:fld id="{5BCAD085-E8A6-8845-BD4E-CB4CCA059FC4}" type="datetimeFigureOut">
               <a:rPr lang="en-US" smtClean="0"/>
-              <a:t>1/27/13</a:t>
+              <a:t>10/3/26</a:t>
             </a:fld>
             <a:endParaRPr lang="en-US"/>
           </a:p>
@@ -3519,10 +3403,9 @@
           </a:lstStyle>
           <a:p>
             <a:r>
-              <a:rPr lang="en-US" smtClean="0"/>
+              <a:rPr lang="en-US"/>
               <a:t>Click to edit Master title style</a:t>
             </a:r>
-            <a:endParaRPr lang="en-US"/>
           </a:p>
         </p:txBody>
       </p:sp>
@@ -3576,38 +3459,37 @@
           <a:p>
             <a:pPr lvl="0"/>
             <a:r>
-              <a:rPr lang="en-US" smtClean="0"/>
+              <a:rPr lang="en-US"/>
               <a:t>Click to edit Master text styles</a:t>
             </a:r>
           </a:p>
           <a:p>
             <a:pPr lvl="1"/>
             <a:r>
-              <a:rPr lang="en-US" smtClean="0"/>
+              <a:rPr lang="en-US"/>
               <a:t>Second level</a:t>
             </a:r>
           </a:p>
           <a:p>
             <a:pPr lvl="2"/>
             <a:r>
-              <a:rPr lang="en-US" smtClean="0"/>
+              <a:rPr lang="en-US"/>
               <a:t>Third level</a:t>
             </a:r>
           </a:p>
           <a:p>
             <a:pPr lvl="3"/>
             <a:r>
-              <a:rPr lang="en-US" smtClean="0"/>
+              <a:rPr lang="en-US"/>
               <a:t>Fourth level</a:t>
             </a:r>
           </a:p>
           <a:p>
             <a:pPr lvl="4"/>
             <a:r>
-              <a:rPr lang="en-US" smtClean="0"/>
+              <a:rPr lang="en-US"/>
               <a:t>Fifth level</a:t>
             </a:r>
-            <a:endParaRPr lang="en-US"/>
           </a:p>
         </p:txBody>
       </p:sp>
@@ -3670,7 +3552,7 @@
           <a:p>
             <a:pPr lvl="0"/>
             <a:r>
-              <a:rPr lang="en-US" smtClean="0"/>
+              <a:rPr lang="en-US"/>
               <a:t>Click to edit Master text styles</a:t>
             </a:r>
           </a:p>
@@ -3693,7 +3575,7 @@
           <a:p>
             <a:fld id="{5BCAD085-E8A6-8845-BD4E-CB4CCA059FC4}" type="datetimeFigureOut">
               <a:rPr lang="en-US" smtClean="0"/>
-              <a:t>1/27/13</a:t>
+              <a:t>10/3/26</a:t>
             </a:fld>
             <a:endParaRPr lang="en-US"/>
           </a:p>
@@ -3796,10 +3678,9 @@
           </a:lstStyle>
           <a:p>
             <a:r>
-              <a:rPr lang="en-US" smtClean="0"/>
+              <a:rPr lang="en-US"/>
               <a:t>Click to edit Master title style</a:t>
             </a:r>
-            <a:endParaRPr lang="en-US"/>
           </a:p>
         </p:txBody>
       </p:sp>
@@ -3923,7 +3804,7 @@
           <a:p>
             <a:pPr lvl="0"/>
             <a:r>
-              <a:rPr lang="en-US" smtClean="0"/>
+              <a:rPr lang="en-US"/>
               <a:t>Click to edit Master text styles</a:t>
             </a:r>
           </a:p>
@@ -3946,7 +3827,7 @@
           <a:p>
             <a:fld id="{5BCAD085-E8A6-8845-BD4E-CB4CCA059FC4}" type="datetimeFigureOut">
               <a:rPr lang="en-US" smtClean="0"/>
-              <a:t>1/27/13</a:t>
+              <a:t>10/3/26</a:t>
             </a:fld>
             <a:endParaRPr lang="en-US"/>
           </a:p>
@@ -4055,10 +3936,9 @@
           <a:lstStyle/>
           <a:p>
             <a:r>
-              <a:rPr lang="en-US" smtClean="0"/>
+              <a:rPr lang="en-US"/>
               <a:t>Click to edit Master title style</a:t>
             </a:r>
-            <a:endParaRPr lang="en-US"/>
           </a:p>
         </p:txBody>
       </p:sp>
@@ -4089,38 +3969,37 @@
           <a:p>
             <a:pPr lvl="0"/>
             <a:r>
-              <a:rPr lang="en-US" smtClean="0"/>
+              <a:rPr lang="en-US"/>
               <a:t>Click to edit Master text styles</a:t>
             </a:r>
           </a:p>
           <a:p>
             <a:pPr lvl="1"/>
             <a:r>
-              <a:rPr lang="en-US" smtClean="0"/>
+              <a:rPr lang="en-US"/>
               <a:t>Second level</a:t>
             </a:r>
           </a:p>
           <a:p>
             <a:pPr lvl="2"/>
             <a:r>
-              <a:rPr lang="en-US" smtClean="0"/>
+              <a:rPr lang="en-US"/>
               <a:t>Third level</a:t>
             </a:r>
           </a:p>
           <a:p>
             <a:pPr lvl="3"/>
             <a:r>
-              <a:rPr lang="en-US" smtClean="0"/>
+              <a:rPr lang="en-US"/>
               <a:t>Fourth level</a:t>
             </a:r>
           </a:p>
           <a:p>
             <a:pPr lvl="4"/>
             <a:r>
-              <a:rPr lang="en-US" smtClean="0"/>
+              <a:rPr lang="en-US"/>
               <a:t>Fifth level</a:t>
             </a:r>
-            <a:endParaRPr lang="en-US"/>
           </a:p>
         </p:txBody>
       </p:sp>
@@ -4159,7 +4038,7 @@
           <a:p>
             <a:fld id="{5BCAD085-E8A6-8845-BD4E-CB4CCA059FC4}" type="datetimeFigureOut">
               <a:rPr lang="en-US" smtClean="0"/>
-              <a:t>1/27/13</a:t>
+              <a:t>10/3/26</a:t>
             </a:fld>
             <a:endParaRPr lang="en-US"/>
           </a:p>
@@ -4518,7 +4397,7 @@
 </file>
 
 <file path=ppt/slides/slide1.xml><?xml version="1.0" encoding="utf-8"?>
-<p:sld xmlns:a="http://schemas.openxmlformats.org/drawingml/2006/main" xmlns:p="http://schemas.openxmlformats.org/presentationml/2006/main" xmlns:r="http://schemas.openxmlformats.org/officeDocument/2006/relationships">
+<p:sld xmlns:a="http://schemas.openxmlformats.org/drawingml/2006/main" xmlns:r="http://schemas.openxmlformats.org/officeDocument/2006/relationships" xmlns:p="http://schemas.openxmlformats.org/presentationml/2006/main">
   <p:cSld>
     <p:spTree>
       <p:nvGrpSpPr>
@@ -4526,7 +4405,14 @@
         <p:cNvGrpSpPr/>
         <p:nvPr/>
       </p:nvGrpSpPr>
-      <p:grpSpPr/>
+      <p:grpSpPr>
+        <a:xfrm>
+          <a:off x="0" y="0"/>
+          <a:ext cx="0" cy="0"/>
+          <a:chOff x="0" y="0"/>
+          <a:chExt cx="0" cy="0"/>
+        </a:xfrm>
+      </p:grpSpPr>
       <p:sp>
         <p:nvSpPr>
           <p:cNvPr id="2" name="Rectangle 1"/>
@@ -4566,7 +4452,9 @@
         <p:txBody>
           <a:bodyPr rtlCol="0" anchor="ctr"/>
           <a:lstStyle/>
-          <a:p/>
+          <a:p>
+            <a:endParaRPr/>
+          </a:p>
         </p:txBody>
       </p:sp>
       <p:sp>
@@ -4608,7 +4496,9 @@
         <p:txBody>
           <a:bodyPr rtlCol="0" anchor="ctr"/>
           <a:lstStyle/>
-          <a:p/>
+          <a:p>
+            <a:endParaRPr/>
+          </a:p>
         </p:txBody>
       </p:sp>
       <p:sp>
@@ -4628,7 +4518,7 @@
           <a:noFill/>
         </p:spPr>
         <p:txBody>
-          <a:bodyPr wrap="square" lIns="0" rIns="0" tIns="0" bIns="0" anchor="t">
+          <a:bodyPr wrap="square" lIns="0" tIns="0" rIns="0" bIns="0" anchor="t">
             <a:spAutoFit/>
           </a:bodyPr>
           <a:lstStyle/>
@@ -4689,7 +4579,7 @@
           <a:noFill/>
         </p:spPr>
         <p:txBody>
-          <a:bodyPr wrap="square" lIns="0" rIns="0" tIns="0" bIns="0" anchor="t">
+          <a:bodyPr wrap="square" lIns="0" tIns="0" rIns="0" bIns="0" anchor="t">
             <a:spAutoFit/>
           </a:bodyPr>
           <a:lstStyle/>
@@ -4723,7 +4613,7 @@
         <p:spPr>
           <a:xfrm>
             <a:off x="548640" y="4800600"/>
-            <a:ext cx="10972800" cy="1280160"/>
+            <a:ext cx="10972800" cy="901529"/>
           </a:xfrm>
           <a:prstGeom prst="rect">
             <a:avLst/>
@@ -4731,7 +4621,7 @@
           <a:noFill/>
         </p:spPr>
         <p:txBody>
-          <a:bodyPr wrap="square" lIns="0" rIns="0" tIns="0" bIns="0" anchor="t">
+          <a:bodyPr wrap="square" lIns="0" tIns="0" rIns="0" bIns="0" anchor="t">
             <a:spAutoFit/>
           </a:bodyPr>
           <a:lstStyle/>
@@ -4745,7 +4635,7 @@
               </a:spcAft>
             </a:pPr>
             <a:r>
-              <a:rPr sz="1600" b="0" i="0">
+              <a:rPr sz="1600" b="0" i="0" dirty="0">
                 <a:solidFill>
                   <a:srgbClr val="C9D3E0"/>
                 </a:solidFill>
@@ -4764,13 +4654,31 @@
               </a:spcAft>
             </a:pPr>
             <a:r>
-              <a:rPr sz="1600" b="0" i="0">
+              <a:rPr sz="1600" b="0" i="0" dirty="0">
                 <a:solidFill>
                   <a:srgbClr val="C9D3E0"/>
                 </a:solidFill>
                 <a:latin typeface="Calibri"/>
               </a:rPr>
-              <a:t>AAI6680: AI for Cybersecurity · Northeastern University · Mimoza Dimodugno, PhD</a:t>
+              <a:t>AAI6680: AI for Cybersecurity · Northeastern University · Mimoza </a:t>
+            </a:r>
+            <a:r>
+              <a:rPr sz="1600" b="0" i="0" dirty="0" err="1">
+                <a:solidFill>
+                  <a:srgbClr val="C9D3E0"/>
+                </a:solidFill>
+                <a:latin typeface="Calibri"/>
+              </a:rPr>
+              <a:t>Dimodugno</a:t>
+            </a:r>
+            <a:r>
+              <a:rPr sz="1600" b="0" i="0" dirty="0">
+                <a:solidFill>
+                  <a:srgbClr val="C9D3E0"/>
+                </a:solidFill>
+                <a:latin typeface="Calibri"/>
+              </a:rPr>
+              <a:t>, PhD</a:t>
             </a:r>
           </a:p>
           <a:p>
@@ -4783,13 +4691,40 @@
               </a:spcAft>
             </a:pPr>
             <a:r>
-              <a:rPr sz="1600" b="0" i="0">
+              <a:rPr lang="en-US" sz="1600" b="0" i="0" dirty="0">
                 <a:solidFill>
                   <a:srgbClr val="C9D3E0"/>
                 </a:solidFill>
                 <a:latin typeface="Calibri"/>
               </a:rPr>
-              <a:t>October 3, 2026</a:t>
+              <a:t>Due Date: </a:t>
+            </a:r>
+            <a:r>
+              <a:rPr sz="1600" b="0" i="0" dirty="0">
+                <a:solidFill>
+                  <a:srgbClr val="C9D3E0"/>
+                </a:solidFill>
+                <a:latin typeface="Calibri"/>
+              </a:rPr>
+              <a:t>October </a:t>
+            </a:r>
+            <a:r>
+              <a:rPr lang="en-US" sz="1600" dirty="0">
+                <a:solidFill>
+                  <a:srgbClr val="C9D3E0"/>
+                </a:solidFill>
+                <a:latin typeface="Calibri"/>
+              </a:rPr>
+              <a:t>4</a:t>
+            </a:r>
+            <a:r>
+              <a:rPr sz="1600" b="0" i="0" dirty="0">
+                <a:solidFill>
+                  <a:srgbClr val="C9D3E0"/>
+                </a:solidFill>
+                <a:latin typeface="Calibri"/>
+              </a:rPr>
+              <a:t>, 2026</a:t>
             </a:r>
           </a:p>
         </p:txBody>
@@ -4803,7 +4738,7 @@
 </file>
 
 <file path=ppt/slides/slide10.xml><?xml version="1.0" encoding="utf-8"?>
-<p:sld xmlns:a="http://schemas.openxmlformats.org/drawingml/2006/main" xmlns:p="http://schemas.openxmlformats.org/presentationml/2006/main" xmlns:r="http://schemas.openxmlformats.org/officeDocument/2006/relationships">
+<p:sld xmlns:a="http://schemas.openxmlformats.org/drawingml/2006/main" xmlns:r="http://schemas.openxmlformats.org/officeDocument/2006/relationships" xmlns:p="http://schemas.openxmlformats.org/presentationml/2006/main">
   <p:cSld>
     <p:spTree>
       <p:nvGrpSpPr>
@@ -4811,7 +4746,14 @@
         <p:cNvGrpSpPr/>
         <p:nvPr/>
       </p:nvGrpSpPr>
-      <p:grpSpPr/>
+      <p:grpSpPr>
+        <a:xfrm>
+          <a:off x="0" y="0"/>
+          <a:ext cx="0" cy="0"/>
+          <a:chOff x="0" y="0"/>
+          <a:chExt cx="0" cy="0"/>
+        </a:xfrm>
+      </p:grpSpPr>
       <p:sp>
         <p:nvSpPr>
           <p:cNvPr id="2" name="Rectangle 1"/>
@@ -4851,7 +4793,9 @@
         <p:txBody>
           <a:bodyPr rtlCol="0" anchor="ctr"/>
           <a:lstStyle/>
-          <a:p/>
+          <a:p>
+            <a:endParaRPr/>
+          </a:p>
         </p:txBody>
       </p:sp>
       <p:sp>
@@ -4871,7 +4815,7 @@
           <a:noFill/>
         </p:spPr>
         <p:txBody>
-          <a:bodyPr wrap="square" lIns="0" rIns="0" tIns="0" bIns="0" anchor="t">
+          <a:bodyPr wrap="square" lIns="0" tIns="0" rIns="0" bIns="0" anchor="t">
             <a:spAutoFit/>
           </a:bodyPr>
           <a:lstStyle/>
@@ -4913,7 +4857,7 @@
           <a:noFill/>
         </p:spPr>
         <p:txBody>
-          <a:bodyPr wrap="square" lIns="0" rIns="0" tIns="0" bIns="0" anchor="t">
+          <a:bodyPr wrap="square" lIns="0" tIns="0" rIns="0" bIns="0" anchor="t">
             <a:spAutoFit/>
           </a:bodyPr>
           <a:lstStyle/>
@@ -4955,12 +4899,12 @@
           <a:noFill/>
         </p:spPr>
         <p:txBody>
-          <a:bodyPr wrap="square" lIns="0" rIns="0" tIns="0" bIns="0" anchor="t">
+          <a:bodyPr wrap="square" lIns="0" tIns="0" rIns="0" bIns="0" anchor="t">
             <a:spAutoFit/>
           </a:bodyPr>
           <a:lstStyle/>
           <a:p>
-            <a:pPr algn="l" marL="411480" indent="-411480">
+            <a:pPr marL="411480" indent="-411480" algn="l">
               <a:lnSpc>
                 <a:spcPct val="100000"/>
               </a:lnSpc>
@@ -4997,7 +4941,7 @@
             </a:r>
           </a:p>
           <a:p>
-            <a:pPr algn="l" marL="411480" indent="-411480">
+            <a:pPr marL="411480" indent="-411480" algn="l">
               <a:lnSpc>
                 <a:spcPct val="100000"/>
               </a:lnSpc>
@@ -5034,7 +4978,7 @@
             </a:r>
           </a:p>
           <a:p>
-            <a:pPr algn="l" marL="411480" indent="-411480">
+            <a:pPr marL="411480" indent="-411480" algn="l">
               <a:lnSpc>
                 <a:spcPct val="100000"/>
               </a:lnSpc>
@@ -5071,7 +5015,7 @@
             </a:r>
           </a:p>
           <a:p>
-            <a:pPr algn="l" marL="411480" indent="-411480">
+            <a:pPr marL="411480" indent="-411480" algn="l">
               <a:lnSpc>
                 <a:spcPct val="100000"/>
               </a:lnSpc>
@@ -5108,7 +5052,7 @@
             </a:r>
           </a:p>
           <a:p>
-            <a:pPr algn="l" marL="411480" indent="-411480">
+            <a:pPr marL="411480" indent="-411480" algn="l">
               <a:lnSpc>
                 <a:spcPct val="100000"/>
               </a:lnSpc>
@@ -5145,7 +5089,7 @@
             </a:r>
           </a:p>
           <a:p>
-            <a:pPr algn="l" marL="411480" indent="-411480">
+            <a:pPr marL="411480" indent="-411480" algn="l">
               <a:lnSpc>
                 <a:spcPct val="100000"/>
               </a:lnSpc>
@@ -5182,7 +5126,7 @@
             </a:r>
           </a:p>
           <a:p>
-            <a:pPr algn="l" marL="411480" indent="-411480">
+            <a:pPr marL="411480" indent="-411480" algn="l">
               <a:lnSpc>
                 <a:spcPct val="100000"/>
               </a:lnSpc>
@@ -5219,7 +5163,7 @@
             </a:r>
           </a:p>
           <a:p>
-            <a:pPr algn="l" marL="411480" indent="-411480">
+            <a:pPr marL="411480" indent="-411480" algn="l">
               <a:lnSpc>
                 <a:spcPct val="100000"/>
               </a:lnSpc>
@@ -5256,7 +5200,7 @@
             </a:r>
           </a:p>
           <a:p>
-            <a:pPr algn="l" marL="411480" indent="-411480">
+            <a:pPr marL="411480" indent="-411480" algn="l">
               <a:lnSpc>
                 <a:spcPct val="100000"/>
               </a:lnSpc>
@@ -5293,7 +5237,7 @@
             </a:r>
           </a:p>
           <a:p>
-            <a:pPr algn="l" marL="411480" indent="-411480">
+            <a:pPr marL="411480" indent="-411480" algn="l">
               <a:lnSpc>
                 <a:spcPct val="100000"/>
               </a:lnSpc>
@@ -5330,7 +5274,7 @@
             </a:r>
           </a:p>
           <a:p>
-            <a:pPr algn="l" marL="411480" indent="-411480">
+            <a:pPr marL="411480" indent="-411480" algn="l">
               <a:lnSpc>
                 <a:spcPct val="100000"/>
               </a:lnSpc>
@@ -5420,7 +5364,7 @@
           <a:noFill/>
         </p:spPr>
         <p:txBody>
-          <a:bodyPr wrap="square" lIns="0" rIns="0" tIns="0" bIns="0" anchor="t">
+          <a:bodyPr wrap="square" lIns="0" tIns="0" rIns="0" bIns="0" anchor="t">
             <a:spAutoFit/>
           </a:bodyPr>
           <a:lstStyle/>
@@ -5462,7 +5406,7 @@
           <a:noFill/>
         </p:spPr>
         <p:txBody>
-          <a:bodyPr wrap="square" lIns="0" rIns="0" tIns="0" bIns="0" anchor="t">
+          <a:bodyPr wrap="square" lIns="0" tIns="0" rIns="0" bIns="0" anchor="t">
             <a:spAutoFit/>
           </a:bodyPr>
           <a:lstStyle/>
@@ -5496,7 +5440,7 @@
 </file>
 
 <file path=ppt/slides/slide2.xml><?xml version="1.0" encoding="utf-8"?>
-<p:sld xmlns:a="http://schemas.openxmlformats.org/drawingml/2006/main" xmlns:p="http://schemas.openxmlformats.org/presentationml/2006/main" xmlns:r="http://schemas.openxmlformats.org/officeDocument/2006/relationships">
+<p:sld xmlns:a="http://schemas.openxmlformats.org/drawingml/2006/main" xmlns:r="http://schemas.openxmlformats.org/officeDocument/2006/relationships" xmlns:p="http://schemas.openxmlformats.org/presentationml/2006/main">
   <p:cSld>
     <p:spTree>
       <p:nvGrpSpPr>
@@ -5504,7 +5448,14 @@
         <p:cNvGrpSpPr/>
         <p:nvPr/>
       </p:nvGrpSpPr>
-      <p:grpSpPr/>
+      <p:grpSpPr>
+        <a:xfrm>
+          <a:off x="0" y="0"/>
+          <a:ext cx="0" cy="0"/>
+          <a:chOff x="0" y="0"/>
+          <a:chExt cx="0" cy="0"/>
+        </a:xfrm>
+      </p:grpSpPr>
       <p:sp>
         <p:nvSpPr>
           <p:cNvPr id="2" name="Rectangle 1"/>
@@ -5544,7 +5495,9 @@
         <p:txBody>
           <a:bodyPr rtlCol="0" anchor="ctr"/>
           <a:lstStyle/>
-          <a:p/>
+          <a:p>
+            <a:endParaRPr/>
+          </a:p>
         </p:txBody>
       </p:sp>
       <p:sp>
@@ -5564,7 +5517,7 @@
           <a:noFill/>
         </p:spPr>
         <p:txBody>
-          <a:bodyPr wrap="square" lIns="0" rIns="0" tIns="0" bIns="0" anchor="t">
+          <a:bodyPr wrap="square" lIns="0" tIns="0" rIns="0" bIns="0" anchor="t">
             <a:spAutoFit/>
           </a:bodyPr>
           <a:lstStyle/>
@@ -5606,7 +5559,7 @@
           <a:noFill/>
         </p:spPr>
         <p:txBody>
-          <a:bodyPr wrap="square" lIns="0" rIns="0" tIns="0" bIns="0" anchor="t">
+          <a:bodyPr wrap="square" lIns="0" tIns="0" rIns="0" bIns="0" anchor="t">
             <a:spAutoFit/>
           </a:bodyPr>
           <a:lstStyle/>
@@ -5648,7 +5601,7 @@
           <a:noFill/>
         </p:spPr>
         <p:txBody>
-          <a:bodyPr wrap="square" lIns="0" rIns="0" tIns="0" bIns="0">
+          <a:bodyPr wrap="square" lIns="0" tIns="0" rIns="0" bIns="0">
             <a:spAutoFit/>
           </a:bodyPr>
           <a:lstStyle/>
@@ -5863,7 +5816,9 @@
         <p:txBody>
           <a:bodyPr rtlCol="0" anchor="ctr"/>
           <a:lstStyle/>
-          <a:p/>
+          <a:p>
+            <a:endParaRPr/>
+          </a:p>
         </p:txBody>
       </p:sp>
       <p:sp>
@@ -5905,7 +5860,9 @@
         <p:txBody>
           <a:bodyPr rtlCol="0" anchor="ctr"/>
           <a:lstStyle/>
-          <a:p/>
+          <a:p>
+            <a:endParaRPr/>
+          </a:p>
         </p:txBody>
       </p:sp>
       <p:sp>
@@ -5925,7 +5882,7 @@
           <a:noFill/>
         </p:spPr>
         <p:txBody>
-          <a:bodyPr wrap="square" lIns="0" rIns="0" tIns="0" bIns="0" anchor="t">
+          <a:bodyPr wrap="square" lIns="0" tIns="0" rIns="0" bIns="0" anchor="t">
             <a:spAutoFit/>
           </a:bodyPr>
           <a:lstStyle/>
@@ -5967,7 +5924,7 @@
           <a:noFill/>
         </p:spPr>
         <p:txBody>
-          <a:bodyPr wrap="square" lIns="0" rIns="0" tIns="0" bIns="0" anchor="t">
+          <a:bodyPr wrap="square" lIns="0" tIns="0" rIns="0" bIns="0" anchor="t">
             <a:spAutoFit/>
           </a:bodyPr>
           <a:lstStyle/>
@@ -6082,7 +6039,7 @@
           <a:noFill/>
         </p:spPr>
         <p:txBody>
-          <a:bodyPr wrap="square" lIns="0" rIns="0" tIns="0" bIns="0" anchor="t">
+          <a:bodyPr wrap="square" lIns="0" tIns="0" rIns="0" bIns="0" anchor="t">
             <a:spAutoFit/>
           </a:bodyPr>
           <a:lstStyle/>
@@ -6124,7 +6081,7 @@
           <a:noFill/>
         </p:spPr>
         <p:txBody>
-          <a:bodyPr wrap="square" lIns="0" rIns="0" tIns="0" bIns="0" anchor="t">
+          <a:bodyPr wrap="square" lIns="0" tIns="0" rIns="0" bIns="0" anchor="t">
             <a:spAutoFit/>
           </a:bodyPr>
           <a:lstStyle/>
@@ -6158,7 +6115,7 @@
 </file>
 
 <file path=ppt/slides/slide3.xml><?xml version="1.0" encoding="utf-8"?>
-<p:sld xmlns:a="http://schemas.openxmlformats.org/drawingml/2006/main" xmlns:p="http://schemas.openxmlformats.org/presentationml/2006/main" xmlns:r="http://schemas.openxmlformats.org/officeDocument/2006/relationships">
+<p:sld xmlns:a="http://schemas.openxmlformats.org/drawingml/2006/main" xmlns:r="http://schemas.openxmlformats.org/officeDocument/2006/relationships" xmlns:p="http://schemas.openxmlformats.org/presentationml/2006/main">
   <p:cSld>
     <p:spTree>
       <p:nvGrpSpPr>
@@ -6166,7 +6123,14 @@
         <p:cNvGrpSpPr/>
         <p:nvPr/>
       </p:nvGrpSpPr>
-      <p:grpSpPr/>
+      <p:grpSpPr>
+        <a:xfrm>
+          <a:off x="0" y="0"/>
+          <a:ext cx="0" cy="0"/>
+          <a:chOff x="0" y="0"/>
+          <a:chExt cx="0" cy="0"/>
+        </a:xfrm>
+      </p:grpSpPr>
       <p:sp>
         <p:nvSpPr>
           <p:cNvPr id="2" name="Rectangle 1"/>
@@ -6206,7 +6170,9 @@
         <p:txBody>
           <a:bodyPr rtlCol="0" anchor="ctr"/>
           <a:lstStyle/>
-          <a:p/>
+          <a:p>
+            <a:endParaRPr/>
+          </a:p>
         </p:txBody>
       </p:sp>
       <p:sp>
@@ -6226,7 +6192,7 @@
           <a:noFill/>
         </p:spPr>
         <p:txBody>
-          <a:bodyPr wrap="square" lIns="0" rIns="0" tIns="0" bIns="0" anchor="t">
+          <a:bodyPr wrap="square" lIns="0" tIns="0" rIns="0" bIns="0" anchor="t">
             <a:spAutoFit/>
           </a:bodyPr>
           <a:lstStyle/>
@@ -6268,7 +6234,7 @@
           <a:noFill/>
         </p:spPr>
         <p:txBody>
-          <a:bodyPr wrap="square" lIns="0" rIns="0" tIns="0" bIns="0" anchor="t">
+          <a:bodyPr wrap="square" lIns="0" tIns="0" rIns="0" bIns="0" anchor="t">
             <a:spAutoFit/>
           </a:bodyPr>
           <a:lstStyle/>
@@ -6334,7 +6300,9 @@
         <p:txBody>
           <a:bodyPr rtlCol="0" anchor="ctr"/>
           <a:lstStyle/>
-          <a:p/>
+          <a:p>
+            <a:endParaRPr/>
+          </a:p>
         </p:txBody>
       </p:sp>
       <p:sp>
@@ -6376,7 +6344,9 @@
         <p:txBody>
           <a:bodyPr rtlCol="0" anchor="ctr"/>
           <a:lstStyle/>
-          <a:p/>
+          <a:p>
+            <a:endParaRPr/>
+          </a:p>
         </p:txBody>
       </p:sp>
       <p:sp>
@@ -6396,7 +6366,7 @@
           <a:noFill/>
         </p:spPr>
         <p:txBody>
-          <a:bodyPr wrap="square" lIns="0" rIns="0" tIns="0" bIns="0" anchor="t">
+          <a:bodyPr wrap="square" lIns="0" tIns="0" rIns="0" bIns="0" anchor="t">
             <a:spAutoFit/>
           </a:bodyPr>
           <a:lstStyle/>
@@ -6438,7 +6408,7 @@
           <a:noFill/>
         </p:spPr>
         <p:txBody>
-          <a:bodyPr wrap="square" lIns="0" rIns="0" tIns="0" bIns="0" anchor="t">
+          <a:bodyPr wrap="square" lIns="0" tIns="0" rIns="0" bIns="0" anchor="t">
             <a:spAutoFit/>
           </a:bodyPr>
           <a:lstStyle/>
@@ -6480,7 +6450,7 @@
           <a:noFill/>
         </p:spPr>
         <p:txBody>
-          <a:bodyPr wrap="square" lIns="0" rIns="0" tIns="0" bIns="0" anchor="t">
+          <a:bodyPr wrap="square" lIns="0" tIns="0" rIns="0" bIns="0" anchor="t">
             <a:spAutoFit/>
           </a:bodyPr>
           <a:lstStyle/>
@@ -6624,7 +6594,9 @@
         <p:txBody>
           <a:bodyPr rtlCol="0" anchor="ctr"/>
           <a:lstStyle/>
-          <a:p/>
+          <a:p>
+            <a:endParaRPr/>
+          </a:p>
         </p:txBody>
       </p:sp>
       <p:sp>
@@ -6666,7 +6638,9 @@
         <p:txBody>
           <a:bodyPr rtlCol="0" anchor="ctr"/>
           <a:lstStyle/>
-          <a:p/>
+          <a:p>
+            <a:endParaRPr/>
+          </a:p>
         </p:txBody>
       </p:sp>
       <p:sp>
@@ -6686,7 +6660,7 @@
           <a:noFill/>
         </p:spPr>
         <p:txBody>
-          <a:bodyPr wrap="square" lIns="0" rIns="0" tIns="0" bIns="0" anchor="t">
+          <a:bodyPr wrap="square" lIns="0" tIns="0" rIns="0" bIns="0" anchor="t">
             <a:spAutoFit/>
           </a:bodyPr>
           <a:lstStyle/>
@@ -6728,7 +6702,7 @@
           <a:noFill/>
         </p:spPr>
         <p:txBody>
-          <a:bodyPr wrap="square" lIns="0" rIns="0" tIns="0" bIns="0" anchor="t">
+          <a:bodyPr wrap="square" lIns="0" tIns="0" rIns="0" bIns="0" anchor="t">
             <a:spAutoFit/>
           </a:bodyPr>
           <a:lstStyle/>
@@ -6770,7 +6744,7 @@
           <a:noFill/>
         </p:spPr>
         <p:txBody>
-          <a:bodyPr wrap="square" lIns="0" rIns="0" tIns="0" bIns="0" anchor="t">
+          <a:bodyPr wrap="square" lIns="0" tIns="0" rIns="0" bIns="0" anchor="t">
             <a:spAutoFit/>
           </a:bodyPr>
           <a:lstStyle/>
@@ -6914,7 +6888,9 @@
         <p:txBody>
           <a:bodyPr rtlCol="0" anchor="ctr"/>
           <a:lstStyle/>
-          <a:p/>
+          <a:p>
+            <a:endParaRPr/>
+          </a:p>
         </p:txBody>
       </p:sp>
       <p:sp>
@@ -6956,7 +6932,9 @@
         <p:txBody>
           <a:bodyPr rtlCol="0" anchor="ctr"/>
           <a:lstStyle/>
-          <a:p/>
+          <a:p>
+            <a:endParaRPr/>
+          </a:p>
         </p:txBody>
       </p:sp>
       <p:sp>
@@ -6976,7 +6954,7 @@
           <a:noFill/>
         </p:spPr>
         <p:txBody>
-          <a:bodyPr wrap="square" lIns="0" rIns="0" tIns="0" bIns="0" anchor="t">
+          <a:bodyPr wrap="square" lIns="0" tIns="0" rIns="0" bIns="0" anchor="t">
             <a:spAutoFit/>
           </a:bodyPr>
           <a:lstStyle/>
@@ -7018,7 +6996,7 @@
           <a:noFill/>
         </p:spPr>
         <p:txBody>
-          <a:bodyPr wrap="square" lIns="0" rIns="0" tIns="0" bIns="0" anchor="t">
+          <a:bodyPr wrap="square" lIns="0" tIns="0" rIns="0" bIns="0" anchor="t">
             <a:spAutoFit/>
           </a:bodyPr>
           <a:lstStyle/>
@@ -7060,7 +7038,7 @@
           <a:noFill/>
         </p:spPr>
         <p:txBody>
-          <a:bodyPr wrap="square" lIns="0" rIns="0" tIns="0" bIns="0" anchor="t">
+          <a:bodyPr wrap="square" lIns="0" tIns="0" rIns="0" bIns="0" anchor="t">
             <a:spAutoFit/>
           </a:bodyPr>
           <a:lstStyle/>
@@ -7215,7 +7193,7 @@
           <a:noFill/>
         </p:spPr>
         <p:txBody>
-          <a:bodyPr wrap="square" lIns="0" rIns="0" tIns="0" bIns="0" anchor="t">
+          <a:bodyPr wrap="square" lIns="0" tIns="0" rIns="0" bIns="0" anchor="t">
             <a:spAutoFit/>
           </a:bodyPr>
           <a:lstStyle/>
@@ -7257,7 +7235,7 @@
           <a:noFill/>
         </p:spPr>
         <p:txBody>
-          <a:bodyPr wrap="square" lIns="0" rIns="0" tIns="0" bIns="0" anchor="t">
+          <a:bodyPr wrap="square" lIns="0" tIns="0" rIns="0" bIns="0" anchor="t">
             <a:spAutoFit/>
           </a:bodyPr>
           <a:lstStyle/>
@@ -7291,7 +7269,7 @@
 </file>
 
 <file path=ppt/slides/slide4.xml><?xml version="1.0" encoding="utf-8"?>
-<p:sld xmlns:a="http://schemas.openxmlformats.org/drawingml/2006/main" xmlns:p="http://schemas.openxmlformats.org/presentationml/2006/main" xmlns:r="http://schemas.openxmlformats.org/officeDocument/2006/relationships">
+<p:sld xmlns:a="http://schemas.openxmlformats.org/drawingml/2006/main" xmlns:r="http://schemas.openxmlformats.org/officeDocument/2006/relationships" xmlns:p="http://schemas.openxmlformats.org/presentationml/2006/main">
   <p:cSld>
     <p:spTree>
       <p:nvGrpSpPr>
@@ -7299,7 +7277,14 @@
         <p:cNvGrpSpPr/>
         <p:nvPr/>
       </p:nvGrpSpPr>
-      <p:grpSpPr/>
+      <p:grpSpPr>
+        <a:xfrm>
+          <a:off x="0" y="0"/>
+          <a:ext cx="0" cy="0"/>
+          <a:chOff x="0" y="0"/>
+          <a:chExt cx="0" cy="0"/>
+        </a:xfrm>
+      </p:grpSpPr>
       <p:sp>
         <p:nvSpPr>
           <p:cNvPr id="2" name="Rectangle 1"/>
@@ -7339,7 +7324,9 @@
         <p:txBody>
           <a:bodyPr rtlCol="0" anchor="ctr"/>
           <a:lstStyle/>
-          <a:p/>
+          <a:p>
+            <a:endParaRPr/>
+          </a:p>
         </p:txBody>
       </p:sp>
       <p:sp>
@@ -7359,7 +7346,7 @@
           <a:noFill/>
         </p:spPr>
         <p:txBody>
-          <a:bodyPr wrap="square" lIns="0" rIns="0" tIns="0" bIns="0" anchor="t">
+          <a:bodyPr wrap="square" lIns="0" tIns="0" rIns="0" bIns="0" anchor="t">
             <a:spAutoFit/>
           </a:bodyPr>
           <a:lstStyle/>
@@ -7401,7 +7388,7 @@
           <a:noFill/>
         </p:spPr>
         <p:txBody>
-          <a:bodyPr wrap="square" lIns="0" rIns="0" tIns="0" bIns="0" anchor="t">
+          <a:bodyPr wrap="square" lIns="0" tIns="0" rIns="0" bIns="0" anchor="t">
             <a:spAutoFit/>
           </a:bodyPr>
           <a:lstStyle/>
@@ -7443,7 +7430,7 @@
           <a:noFill/>
         </p:spPr>
         <p:txBody>
-          <a:bodyPr wrap="square" lIns="0" rIns="0" tIns="0" bIns="0">
+          <a:bodyPr wrap="square" lIns="0" tIns="0" rIns="0" bIns="0">
             <a:spAutoFit/>
           </a:bodyPr>
           <a:lstStyle/>
@@ -7562,7 +7549,7 @@
         </p:xfrm>
         <a:graphic>
           <a:graphicData uri="http://schemas.openxmlformats.org/drawingml/2006/chart">
-            <c:chart xmlns:c="http://schemas.openxmlformats.org/drawingml/2006/chart" r:id="rId2"/>
+            <c:chart xmlns:c="http://schemas.openxmlformats.org/drawingml/2006/chart" xmlns:r="http://schemas.openxmlformats.org/officeDocument/2006/relationships" r:id="rId3"/>
           </a:graphicData>
         </a:graphic>
       </p:graphicFrame>
@@ -7580,7 +7567,7 @@
         </p:xfrm>
         <a:graphic>
           <a:graphicData uri="http://schemas.openxmlformats.org/drawingml/2006/chart">
-            <c:chart xmlns:c="http://schemas.openxmlformats.org/drawingml/2006/chart" r:id="rId3"/>
+            <c:chart xmlns:c="http://schemas.openxmlformats.org/drawingml/2006/chart" xmlns:r="http://schemas.openxmlformats.org/officeDocument/2006/relationships" r:id="rId4"/>
           </a:graphicData>
         </a:graphic>
       </p:graphicFrame>
@@ -7601,7 +7588,7 @@
           <a:noFill/>
         </p:spPr>
         <p:txBody>
-          <a:bodyPr wrap="square" lIns="0" rIns="0" tIns="0" bIns="0" anchor="t">
+          <a:bodyPr wrap="square" lIns="0" tIns="0" rIns="0" bIns="0" anchor="t">
             <a:spAutoFit/>
           </a:bodyPr>
           <a:lstStyle/>
@@ -7687,7 +7674,7 @@
           <a:noFill/>
         </p:spPr>
         <p:txBody>
-          <a:bodyPr wrap="square" lIns="0" rIns="0" tIns="0" bIns="0" anchor="t">
+          <a:bodyPr wrap="square" lIns="0" tIns="0" rIns="0" bIns="0" anchor="t">
             <a:spAutoFit/>
           </a:bodyPr>
           <a:lstStyle/>
@@ -7729,7 +7716,7 @@
           <a:noFill/>
         </p:spPr>
         <p:txBody>
-          <a:bodyPr wrap="square" lIns="0" rIns="0" tIns="0" bIns="0" anchor="t">
+          <a:bodyPr wrap="square" lIns="0" tIns="0" rIns="0" bIns="0" anchor="t">
             <a:spAutoFit/>
           </a:bodyPr>
           <a:lstStyle/>
@@ -7763,7 +7750,7 @@
 </file>
 
 <file path=ppt/slides/slide5.xml><?xml version="1.0" encoding="utf-8"?>
-<p:sld xmlns:a="http://schemas.openxmlformats.org/drawingml/2006/main" xmlns:p="http://schemas.openxmlformats.org/presentationml/2006/main" xmlns:r="http://schemas.openxmlformats.org/officeDocument/2006/relationships">
+<p:sld xmlns:a="http://schemas.openxmlformats.org/drawingml/2006/main" xmlns:r="http://schemas.openxmlformats.org/officeDocument/2006/relationships" xmlns:p="http://schemas.openxmlformats.org/presentationml/2006/main">
   <p:cSld>
     <p:spTree>
       <p:nvGrpSpPr>
@@ -7771,7 +7758,14 @@
         <p:cNvGrpSpPr/>
         <p:nvPr/>
       </p:nvGrpSpPr>
-      <p:grpSpPr/>
+      <p:grpSpPr>
+        <a:xfrm>
+          <a:off x="0" y="0"/>
+          <a:ext cx="0" cy="0"/>
+          <a:chOff x="0" y="0"/>
+          <a:chExt cx="0" cy="0"/>
+        </a:xfrm>
+      </p:grpSpPr>
       <p:sp>
         <p:nvSpPr>
           <p:cNvPr id="2" name="Rectangle 1"/>
@@ -7811,7 +7805,9 @@
         <p:txBody>
           <a:bodyPr rtlCol="0" anchor="ctr"/>
           <a:lstStyle/>
-          <a:p/>
+          <a:p>
+            <a:endParaRPr/>
+          </a:p>
         </p:txBody>
       </p:sp>
       <p:sp>
@@ -7831,7 +7827,7 @@
           <a:noFill/>
         </p:spPr>
         <p:txBody>
-          <a:bodyPr wrap="square" lIns="0" rIns="0" tIns="0" bIns="0" anchor="t">
+          <a:bodyPr wrap="square" lIns="0" tIns="0" rIns="0" bIns="0" anchor="t">
             <a:spAutoFit/>
           </a:bodyPr>
           <a:lstStyle/>
@@ -7873,7 +7869,7 @@
           <a:noFill/>
         </p:spPr>
         <p:txBody>
-          <a:bodyPr wrap="square" lIns="0" rIns="0" tIns="0" bIns="0" anchor="t">
+          <a:bodyPr wrap="square" lIns="0" tIns="0" rIns="0" bIns="0" anchor="t">
             <a:spAutoFit/>
           </a:bodyPr>
           <a:lstStyle/>
@@ -7939,7 +7935,9 @@
         <p:txBody>
           <a:bodyPr rtlCol="0" anchor="ctr"/>
           <a:lstStyle/>
-          <a:p/>
+          <a:p>
+            <a:endParaRPr/>
+          </a:p>
         </p:txBody>
       </p:sp>
       <p:sp>
@@ -7959,7 +7957,7 @@
           <a:noFill/>
         </p:spPr>
         <p:txBody>
-          <a:bodyPr wrap="square" lIns="0" rIns="0" tIns="0" bIns="0" anchor="t">
+          <a:bodyPr wrap="square" lIns="0" tIns="0" rIns="0" bIns="0" anchor="t">
             <a:spAutoFit/>
           </a:bodyPr>
           <a:lstStyle/>
@@ -8001,7 +7999,7 @@
           <a:noFill/>
         </p:spPr>
         <p:txBody>
-          <a:bodyPr wrap="square" lIns="0" rIns="0" tIns="0" bIns="0">
+          <a:bodyPr wrap="square" lIns="0" tIns="0" rIns="0" bIns="0">
             <a:spAutoFit/>
           </a:bodyPr>
           <a:lstStyle/>
@@ -8156,7 +8154,7 @@
           <a:noFill/>
         </p:spPr>
         <p:txBody>
-          <a:bodyPr wrap="square" lIns="0" rIns="0" tIns="0" bIns="0" anchor="t">
+          <a:bodyPr wrap="square" lIns="0" tIns="0" rIns="0" bIns="0" anchor="t">
             <a:spAutoFit/>
           </a:bodyPr>
           <a:lstStyle/>
@@ -8198,7 +8196,7 @@
           <a:noFill/>
         </p:spPr>
         <p:txBody>
-          <a:bodyPr wrap="square" lIns="0" rIns="0" tIns="0" bIns="0">
+          <a:bodyPr wrap="square" lIns="0" tIns="0" rIns="0" bIns="0">
             <a:spAutoFit/>
           </a:bodyPr>
           <a:lstStyle/>
@@ -8388,7 +8386,7 @@
           <a:noFill/>
         </p:spPr>
         <p:txBody>
-          <a:bodyPr wrap="square" lIns="0" rIns="0" tIns="0" bIns="0" anchor="t">
+          <a:bodyPr wrap="square" lIns="0" tIns="0" rIns="0" bIns="0" anchor="t">
             <a:spAutoFit/>
           </a:bodyPr>
           <a:lstStyle/>
@@ -8430,7 +8428,7 @@
           <a:noFill/>
         </p:spPr>
         <p:txBody>
-          <a:bodyPr wrap="square" lIns="0" rIns="0" tIns="0" bIns="0" anchor="t">
+          <a:bodyPr wrap="square" lIns="0" tIns="0" rIns="0" bIns="0" anchor="t">
             <a:spAutoFit/>
           </a:bodyPr>
           <a:lstStyle/>
@@ -8464,7 +8462,7 @@
 </file>
 
 <file path=ppt/slides/slide6.xml><?xml version="1.0" encoding="utf-8"?>
-<p:sld xmlns:a="http://schemas.openxmlformats.org/drawingml/2006/main" xmlns:p="http://schemas.openxmlformats.org/presentationml/2006/main" xmlns:r="http://schemas.openxmlformats.org/officeDocument/2006/relationships">
+<p:sld xmlns:a="http://schemas.openxmlformats.org/drawingml/2006/main" xmlns:r="http://schemas.openxmlformats.org/officeDocument/2006/relationships" xmlns:p="http://schemas.openxmlformats.org/presentationml/2006/main">
   <p:cSld>
     <p:spTree>
       <p:nvGrpSpPr>
@@ -8472,7 +8470,14 @@
         <p:cNvGrpSpPr/>
         <p:nvPr/>
       </p:nvGrpSpPr>
-      <p:grpSpPr/>
+      <p:grpSpPr>
+        <a:xfrm>
+          <a:off x="0" y="0"/>
+          <a:ext cx="0" cy="0"/>
+          <a:chOff x="0" y="0"/>
+          <a:chExt cx="0" cy="0"/>
+        </a:xfrm>
+      </p:grpSpPr>
       <p:sp>
         <p:nvSpPr>
           <p:cNvPr id="2" name="Rectangle 1"/>
@@ -8512,7 +8517,9 @@
         <p:txBody>
           <a:bodyPr rtlCol="0" anchor="ctr"/>
           <a:lstStyle/>
-          <a:p/>
+          <a:p>
+            <a:endParaRPr/>
+          </a:p>
         </p:txBody>
       </p:sp>
       <p:sp>
@@ -8532,7 +8539,7 @@
           <a:noFill/>
         </p:spPr>
         <p:txBody>
-          <a:bodyPr wrap="square" lIns="0" rIns="0" tIns="0" bIns="0" anchor="t">
+          <a:bodyPr wrap="square" lIns="0" tIns="0" rIns="0" bIns="0" anchor="t">
             <a:spAutoFit/>
           </a:bodyPr>
           <a:lstStyle/>
@@ -8574,7 +8581,7 @@
           <a:noFill/>
         </p:spPr>
         <p:txBody>
-          <a:bodyPr wrap="square" lIns="0" rIns="0" tIns="0" bIns="0" anchor="t">
+          <a:bodyPr wrap="square" lIns="0" tIns="0" rIns="0" bIns="0" anchor="t">
             <a:spAutoFit/>
           </a:bodyPr>
           <a:lstStyle/>
@@ -8616,7 +8623,7 @@
           <a:noFill/>
         </p:spPr>
         <p:txBody>
-          <a:bodyPr wrap="square" lIns="0" rIns="0" tIns="0" bIns="0" anchor="t">
+          <a:bodyPr wrap="square" lIns="0" tIns="0" rIns="0" bIns="0" anchor="t">
             <a:spAutoFit/>
           </a:bodyPr>
           <a:lstStyle/>
@@ -8700,7 +8707,9 @@
         <p:txBody>
           <a:bodyPr rtlCol="0" anchor="ctr"/>
           <a:lstStyle/>
-          <a:p/>
+          <a:p>
+            <a:endParaRPr/>
+          </a:p>
         </p:txBody>
       </p:sp>
       <p:sp>
@@ -8742,7 +8751,9 @@
         <p:txBody>
           <a:bodyPr rtlCol="0" anchor="ctr"/>
           <a:lstStyle/>
-          <a:p/>
+          <a:p>
+            <a:endParaRPr/>
+          </a:p>
         </p:txBody>
       </p:sp>
       <p:sp>
@@ -8762,7 +8773,7 @@
           <a:noFill/>
         </p:spPr>
         <p:txBody>
-          <a:bodyPr wrap="square" lIns="0" rIns="0" tIns="0" bIns="0" anchor="t">
+          <a:bodyPr wrap="square" lIns="0" tIns="0" rIns="0" bIns="0" anchor="t">
             <a:spAutoFit/>
           </a:bodyPr>
           <a:lstStyle/>
@@ -8804,7 +8815,7 @@
           <a:noFill/>
         </p:spPr>
         <p:txBody>
-          <a:bodyPr wrap="square" lIns="0" rIns="0" tIns="0" bIns="0" anchor="t">
+          <a:bodyPr wrap="square" lIns="0" tIns="0" rIns="0" bIns="0" anchor="t">
             <a:spAutoFit/>
           </a:bodyPr>
           <a:lstStyle/>
@@ -8846,7 +8857,7 @@
           <a:noFill/>
         </p:spPr>
         <p:txBody>
-          <a:bodyPr wrap="square" lIns="0" rIns="0" tIns="0" bIns="0" anchor="t">
+          <a:bodyPr wrap="square" lIns="0" tIns="0" rIns="0" bIns="0" anchor="t">
             <a:spAutoFit/>
           </a:bodyPr>
           <a:lstStyle/>
@@ -8981,7 +8992,9 @@
         <p:txBody>
           <a:bodyPr rtlCol="0" anchor="ctr"/>
           <a:lstStyle/>
-          <a:p/>
+          <a:p>
+            <a:endParaRPr/>
+          </a:p>
         </p:txBody>
       </p:sp>
       <p:sp>
@@ -9023,7 +9036,9 @@
         <p:txBody>
           <a:bodyPr rtlCol="0" anchor="ctr"/>
           <a:lstStyle/>
-          <a:p/>
+          <a:p>
+            <a:endParaRPr/>
+          </a:p>
         </p:txBody>
       </p:sp>
       <p:sp>
@@ -9043,7 +9058,7 @@
           <a:noFill/>
         </p:spPr>
         <p:txBody>
-          <a:bodyPr wrap="square" lIns="0" rIns="0" tIns="0" bIns="0" anchor="t">
+          <a:bodyPr wrap="square" lIns="0" tIns="0" rIns="0" bIns="0" anchor="t">
             <a:spAutoFit/>
           </a:bodyPr>
           <a:lstStyle/>
@@ -9085,7 +9100,7 @@
           <a:noFill/>
         </p:spPr>
         <p:txBody>
-          <a:bodyPr wrap="square" lIns="0" rIns="0" tIns="0" bIns="0" anchor="t">
+          <a:bodyPr wrap="square" lIns="0" tIns="0" rIns="0" bIns="0" anchor="t">
             <a:spAutoFit/>
           </a:bodyPr>
           <a:lstStyle/>
@@ -9127,7 +9142,7 @@
           <a:noFill/>
         </p:spPr>
         <p:txBody>
-          <a:bodyPr wrap="square" lIns="0" rIns="0" tIns="0" bIns="0" anchor="t">
+          <a:bodyPr wrap="square" lIns="0" tIns="0" rIns="0" bIns="0" anchor="t">
             <a:spAutoFit/>
           </a:bodyPr>
           <a:lstStyle/>
@@ -9271,7 +9286,9 @@
         <p:txBody>
           <a:bodyPr rtlCol="0" anchor="ctr"/>
           <a:lstStyle/>
-          <a:p/>
+          <a:p>
+            <a:endParaRPr/>
+          </a:p>
         </p:txBody>
       </p:sp>
       <p:sp>
@@ -9313,7 +9330,9 @@
         <p:txBody>
           <a:bodyPr rtlCol="0" anchor="ctr"/>
           <a:lstStyle/>
-          <a:p/>
+          <a:p>
+            <a:endParaRPr/>
+          </a:p>
         </p:txBody>
       </p:sp>
       <p:sp>
@@ -9333,7 +9352,7 @@
           <a:noFill/>
         </p:spPr>
         <p:txBody>
-          <a:bodyPr wrap="square" lIns="0" rIns="0" tIns="0" bIns="0" anchor="t">
+          <a:bodyPr wrap="square" lIns="0" tIns="0" rIns="0" bIns="0" anchor="t">
             <a:spAutoFit/>
           </a:bodyPr>
           <a:lstStyle/>
@@ -9375,7 +9394,7 @@
           <a:noFill/>
         </p:spPr>
         <p:txBody>
-          <a:bodyPr wrap="square" lIns="0" rIns="0" tIns="0" bIns="0" anchor="t">
+          <a:bodyPr wrap="square" lIns="0" tIns="0" rIns="0" bIns="0" anchor="t">
             <a:spAutoFit/>
           </a:bodyPr>
           <a:lstStyle/>
@@ -9417,7 +9436,7 @@
           <a:noFill/>
         </p:spPr>
         <p:txBody>
-          <a:bodyPr wrap="square" lIns="0" rIns="0" tIns="0" bIns="0" anchor="t">
+          <a:bodyPr wrap="square" lIns="0" tIns="0" rIns="0" bIns="0" anchor="t">
             <a:spAutoFit/>
           </a:bodyPr>
           <a:lstStyle/>
@@ -9554,7 +9573,7 @@
           <a:noFill/>
         </p:spPr>
         <p:txBody>
-          <a:bodyPr wrap="square" lIns="0" rIns="0" tIns="0" bIns="0" anchor="t">
+          <a:bodyPr wrap="square" lIns="0" tIns="0" rIns="0" bIns="0" anchor="t">
             <a:spAutoFit/>
           </a:bodyPr>
           <a:lstStyle/>
@@ -9596,7 +9615,7 @@
           <a:noFill/>
         </p:spPr>
         <p:txBody>
-          <a:bodyPr wrap="square" lIns="0" rIns="0" tIns="0" bIns="0" anchor="t">
+          <a:bodyPr wrap="square" lIns="0" tIns="0" rIns="0" bIns="0" anchor="t">
             <a:spAutoFit/>
           </a:bodyPr>
           <a:lstStyle/>
@@ -9630,7 +9649,7 @@
 </file>
 
 <file path=ppt/slides/slide7.xml><?xml version="1.0" encoding="utf-8"?>
-<p:sld xmlns:a="http://schemas.openxmlformats.org/drawingml/2006/main" xmlns:p="http://schemas.openxmlformats.org/presentationml/2006/main" xmlns:r="http://schemas.openxmlformats.org/officeDocument/2006/relationships">
+<p:sld xmlns:a="http://schemas.openxmlformats.org/drawingml/2006/main" xmlns:r="http://schemas.openxmlformats.org/officeDocument/2006/relationships" xmlns:p="http://schemas.openxmlformats.org/presentationml/2006/main">
   <p:cSld>
     <p:spTree>
       <p:nvGrpSpPr>
@@ -9638,7 +9657,14 @@
         <p:cNvGrpSpPr/>
         <p:nvPr/>
       </p:nvGrpSpPr>
-      <p:grpSpPr/>
+      <p:grpSpPr>
+        <a:xfrm>
+          <a:off x="0" y="0"/>
+          <a:ext cx="0" cy="0"/>
+          <a:chOff x="0" y="0"/>
+          <a:chExt cx="0" cy="0"/>
+        </a:xfrm>
+      </p:grpSpPr>
       <p:sp>
         <p:nvSpPr>
           <p:cNvPr id="2" name="Rectangle 1"/>
@@ -9678,7 +9704,9 @@
         <p:txBody>
           <a:bodyPr rtlCol="0" anchor="ctr"/>
           <a:lstStyle/>
-          <a:p/>
+          <a:p>
+            <a:endParaRPr/>
+          </a:p>
         </p:txBody>
       </p:sp>
       <p:sp>
@@ -9698,7 +9726,7 @@
           <a:noFill/>
         </p:spPr>
         <p:txBody>
-          <a:bodyPr wrap="square" lIns="0" rIns="0" tIns="0" bIns="0" anchor="t">
+          <a:bodyPr wrap="square" lIns="0" tIns="0" rIns="0" bIns="0" anchor="t">
             <a:spAutoFit/>
           </a:bodyPr>
           <a:lstStyle/>
@@ -9740,7 +9768,7 @@
           <a:noFill/>
         </p:spPr>
         <p:txBody>
-          <a:bodyPr wrap="square" lIns="0" rIns="0" tIns="0" bIns="0" anchor="t">
+          <a:bodyPr wrap="square" lIns="0" tIns="0" rIns="0" bIns="0" anchor="t">
             <a:spAutoFit/>
           </a:bodyPr>
           <a:lstStyle/>
@@ -9804,7 +9832,9 @@
         <p:txBody>
           <a:bodyPr rtlCol="0" anchor="ctr"/>
           <a:lstStyle/>
-          <a:p/>
+          <a:p>
+            <a:endParaRPr/>
+          </a:p>
         </p:txBody>
       </p:sp>
       <p:sp>
@@ -9824,7 +9854,7 @@
           <a:noFill/>
         </p:spPr>
         <p:txBody>
-          <a:bodyPr wrap="square" lIns="0" rIns="0" tIns="0" bIns="0" anchor="t">
+          <a:bodyPr wrap="square" lIns="0" tIns="0" rIns="0" bIns="0" anchor="t">
             <a:spAutoFit/>
           </a:bodyPr>
           <a:lstStyle/>
@@ -9888,7 +9918,9 @@
         <p:txBody>
           <a:bodyPr rtlCol="0" anchor="ctr"/>
           <a:lstStyle/>
-          <a:p/>
+          <a:p>
+            <a:endParaRPr/>
+          </a:p>
         </p:txBody>
       </p:sp>
       <p:sp>
@@ -9908,7 +9940,7 @@
           <a:noFill/>
         </p:spPr>
         <p:txBody>
-          <a:bodyPr wrap="square" lIns="0" rIns="0" tIns="0" bIns="0" anchor="t">
+          <a:bodyPr wrap="square" lIns="0" tIns="0" rIns="0" bIns="0" anchor="t">
             <a:spAutoFit/>
           </a:bodyPr>
           <a:lstStyle/>
@@ -9950,7 +9982,7 @@
           <a:noFill/>
         </p:spPr>
         <p:txBody>
-          <a:bodyPr wrap="square" lIns="0" rIns="0" tIns="0" bIns="0" anchor="t">
+          <a:bodyPr wrap="square" lIns="0" tIns="0" rIns="0" bIns="0" anchor="t">
             <a:spAutoFit/>
           </a:bodyPr>
           <a:lstStyle/>
@@ -9992,7 +10024,7 @@
           <a:noFill/>
         </p:spPr>
         <p:txBody>
-          <a:bodyPr wrap="square" lIns="0" rIns="0" tIns="0" bIns="0" anchor="t">
+          <a:bodyPr wrap="square" lIns="0" tIns="0" rIns="0" bIns="0" anchor="t">
             <a:spAutoFit/>
           </a:bodyPr>
           <a:lstStyle/>
@@ -10034,7 +10066,7 @@
           <a:noFill/>
         </p:spPr>
         <p:txBody>
-          <a:bodyPr wrap="square" lIns="0" rIns="0" tIns="0" bIns="0" anchor="t">
+          <a:bodyPr wrap="square" lIns="0" tIns="0" rIns="0" bIns="0" anchor="t">
             <a:spAutoFit/>
           </a:bodyPr>
           <a:lstStyle/>
@@ -10111,7 +10143,7 @@
           <a:noFill/>
         </p:spPr>
         <p:txBody>
-          <a:bodyPr wrap="square" lIns="0" rIns="0" tIns="0" bIns="0" anchor="t">
+          <a:bodyPr wrap="square" lIns="0" tIns="0" rIns="0" bIns="0" anchor="t">
             <a:spAutoFit/>
           </a:bodyPr>
           <a:lstStyle/>
@@ -10153,7 +10185,7 @@
           <a:noFill/>
         </p:spPr>
         <p:txBody>
-          <a:bodyPr wrap="square" lIns="0" rIns="0" tIns="0" bIns="0" anchor="t">
+          <a:bodyPr wrap="square" lIns="0" tIns="0" rIns="0" bIns="0" anchor="t">
             <a:spAutoFit/>
           </a:bodyPr>
           <a:lstStyle/>
@@ -10195,7 +10227,7 @@
           <a:noFill/>
         </p:spPr>
         <p:txBody>
-          <a:bodyPr wrap="square" lIns="0" rIns="0" tIns="0" bIns="0" anchor="t">
+          <a:bodyPr wrap="square" lIns="0" tIns="0" rIns="0" bIns="0" anchor="t">
             <a:spAutoFit/>
           </a:bodyPr>
           <a:lstStyle/>
@@ -10272,7 +10304,7 @@
           <a:noFill/>
         </p:spPr>
         <p:txBody>
-          <a:bodyPr wrap="square" lIns="0" rIns="0" tIns="0" bIns="0" anchor="t">
+          <a:bodyPr wrap="square" lIns="0" tIns="0" rIns="0" bIns="0" anchor="t">
             <a:spAutoFit/>
           </a:bodyPr>
           <a:lstStyle/>
@@ -10314,7 +10346,7 @@
           <a:noFill/>
         </p:spPr>
         <p:txBody>
-          <a:bodyPr wrap="square" lIns="0" rIns="0" tIns="0" bIns="0" anchor="t">
+          <a:bodyPr wrap="square" lIns="0" tIns="0" rIns="0" bIns="0" anchor="t">
             <a:spAutoFit/>
           </a:bodyPr>
           <a:lstStyle/>
@@ -10356,7 +10388,7 @@
           <a:noFill/>
         </p:spPr>
         <p:txBody>
-          <a:bodyPr wrap="square" lIns="0" rIns="0" tIns="0" bIns="0" anchor="t">
+          <a:bodyPr wrap="square" lIns="0" tIns="0" rIns="0" bIns="0" anchor="t">
             <a:spAutoFit/>
           </a:bodyPr>
           <a:lstStyle/>
@@ -10433,7 +10465,7 @@
           <a:noFill/>
         </p:spPr>
         <p:txBody>
-          <a:bodyPr wrap="square" lIns="0" rIns="0" tIns="0" bIns="0" anchor="t">
+          <a:bodyPr wrap="square" lIns="0" tIns="0" rIns="0" bIns="0" anchor="t">
             <a:spAutoFit/>
           </a:bodyPr>
           <a:lstStyle/>
@@ -10475,7 +10507,7 @@
           <a:noFill/>
         </p:spPr>
         <p:txBody>
-          <a:bodyPr wrap="square" lIns="0" rIns="0" tIns="0" bIns="0" anchor="t">
+          <a:bodyPr wrap="square" lIns="0" tIns="0" rIns="0" bIns="0" anchor="t">
             <a:spAutoFit/>
           </a:bodyPr>
           <a:lstStyle/>
@@ -10517,7 +10549,7 @@
           <a:noFill/>
         </p:spPr>
         <p:txBody>
-          <a:bodyPr wrap="square" lIns="0" rIns="0" tIns="0" bIns="0" anchor="t">
+          <a:bodyPr wrap="square" lIns="0" tIns="0" rIns="0" bIns="0" anchor="t">
             <a:spAutoFit/>
           </a:bodyPr>
           <a:lstStyle/>
@@ -10594,7 +10626,7 @@
           <a:noFill/>
         </p:spPr>
         <p:txBody>
-          <a:bodyPr wrap="square" lIns="0" rIns="0" tIns="0" bIns="0" anchor="t">
+          <a:bodyPr wrap="square" lIns="0" tIns="0" rIns="0" bIns="0" anchor="t">
             <a:spAutoFit/>
           </a:bodyPr>
           <a:lstStyle/>
@@ -10636,7 +10668,7 @@
           <a:noFill/>
         </p:spPr>
         <p:txBody>
-          <a:bodyPr wrap="square" lIns="0" rIns="0" tIns="0" bIns="0">
+          <a:bodyPr wrap="square" lIns="0" tIns="0" rIns="0" bIns="0">
             <a:spAutoFit/>
           </a:bodyPr>
           <a:lstStyle/>
@@ -10793,7 +10825,7 @@
           <a:noFill/>
         </p:spPr>
         <p:txBody>
-          <a:bodyPr wrap="square" lIns="0" rIns="0" tIns="0" bIns="0" anchor="t">
+          <a:bodyPr wrap="square" lIns="0" tIns="0" rIns="0" bIns="0" anchor="t">
             <a:spAutoFit/>
           </a:bodyPr>
           <a:lstStyle/>
@@ -10835,7 +10867,7 @@
           <a:noFill/>
         </p:spPr>
         <p:txBody>
-          <a:bodyPr wrap="square" lIns="0" rIns="0" tIns="0" bIns="0" anchor="t">
+          <a:bodyPr wrap="square" lIns="0" tIns="0" rIns="0" bIns="0" anchor="t">
             <a:spAutoFit/>
           </a:bodyPr>
           <a:lstStyle/>
@@ -10869,7 +10901,7 @@
 </file>
 
 <file path=ppt/slides/slide8.xml><?xml version="1.0" encoding="utf-8"?>
-<p:sld xmlns:a="http://schemas.openxmlformats.org/drawingml/2006/main" xmlns:p="http://schemas.openxmlformats.org/presentationml/2006/main" xmlns:r="http://schemas.openxmlformats.org/officeDocument/2006/relationships">
+<p:sld xmlns:a="http://schemas.openxmlformats.org/drawingml/2006/main" xmlns:r="http://schemas.openxmlformats.org/officeDocument/2006/relationships" xmlns:p="http://schemas.openxmlformats.org/presentationml/2006/main">
   <p:cSld>
     <p:spTree>
       <p:nvGrpSpPr>
@@ -10877,7 +10909,14 @@
         <p:cNvGrpSpPr/>
         <p:nvPr/>
       </p:nvGrpSpPr>
-      <p:grpSpPr/>
+      <p:grpSpPr>
+        <a:xfrm>
+          <a:off x="0" y="0"/>
+          <a:ext cx="0" cy="0"/>
+          <a:chOff x="0" y="0"/>
+          <a:chExt cx="0" cy="0"/>
+        </a:xfrm>
+      </p:grpSpPr>
       <p:sp>
         <p:nvSpPr>
           <p:cNvPr id="2" name="Rectangle 1"/>
@@ -10917,7 +10956,9 @@
         <p:txBody>
           <a:bodyPr rtlCol="0" anchor="ctr"/>
           <a:lstStyle/>
-          <a:p/>
+          <a:p>
+            <a:endParaRPr/>
+          </a:p>
         </p:txBody>
       </p:sp>
       <p:sp>
@@ -10937,7 +10978,7 @@
           <a:noFill/>
         </p:spPr>
         <p:txBody>
-          <a:bodyPr wrap="square" lIns="0" rIns="0" tIns="0" bIns="0" anchor="t">
+          <a:bodyPr wrap="square" lIns="0" tIns="0" rIns="0" bIns="0" anchor="t">
             <a:spAutoFit/>
           </a:bodyPr>
           <a:lstStyle/>
@@ -10979,7 +11020,7 @@
           <a:noFill/>
         </p:spPr>
         <p:txBody>
-          <a:bodyPr wrap="square" lIns="0" rIns="0" tIns="0" bIns="0" anchor="t">
+          <a:bodyPr wrap="square" lIns="0" tIns="0" rIns="0" bIns="0" anchor="t">
             <a:spAutoFit/>
           </a:bodyPr>
           <a:lstStyle/>
@@ -11045,7 +11086,9 @@
         <p:txBody>
           <a:bodyPr rtlCol="0" anchor="ctr"/>
           <a:lstStyle/>
-          <a:p/>
+          <a:p>
+            <a:endParaRPr/>
+          </a:p>
         </p:txBody>
       </p:sp>
       <p:sp>
@@ -11065,7 +11108,7 @@
           <a:noFill/>
         </p:spPr>
         <p:txBody>
-          <a:bodyPr wrap="square" lIns="0" rIns="0" tIns="0" bIns="0" anchor="t">
+          <a:bodyPr wrap="square" lIns="0" tIns="0" rIns="0" bIns="0" anchor="t">
             <a:spAutoFit/>
           </a:bodyPr>
           <a:lstStyle/>
@@ -11107,7 +11150,7 @@
           <a:noFill/>
         </p:spPr>
         <p:txBody>
-          <a:bodyPr wrap="square" lIns="0" rIns="0" tIns="0" bIns="0" anchor="t">
+          <a:bodyPr wrap="square" lIns="0" tIns="0" rIns="0" bIns="0" anchor="t">
             <a:spAutoFit/>
           </a:bodyPr>
           <a:lstStyle/>
@@ -11214,7 +11257,7 @@
           <a:noFill/>
         </p:spPr>
         <p:txBody>
-          <a:bodyPr wrap="square" lIns="0" rIns="0" tIns="0" bIns="0" anchor="t">
+          <a:bodyPr wrap="square" lIns="0" tIns="0" rIns="0" bIns="0" anchor="t">
             <a:spAutoFit/>
           </a:bodyPr>
           <a:lstStyle/>
@@ -11256,7 +11299,7 @@
           <a:noFill/>
         </p:spPr>
         <p:txBody>
-          <a:bodyPr wrap="square" lIns="0" rIns="0" tIns="0" bIns="0">
+          <a:bodyPr wrap="square" lIns="0" tIns="0" rIns="0" bIns="0">
             <a:spAutoFit/>
           </a:bodyPr>
           <a:lstStyle/>
@@ -11378,7 +11421,7 @@
           <a:noFill/>
         </p:spPr>
         <p:txBody>
-          <a:bodyPr wrap="square" lIns="0" rIns="0" tIns="0" bIns="0" anchor="t">
+          <a:bodyPr wrap="square" lIns="0" tIns="0" rIns="0" bIns="0" anchor="t">
             <a:spAutoFit/>
           </a:bodyPr>
           <a:lstStyle/>
@@ -11420,7 +11463,7 @@
           <a:noFill/>
         </p:spPr>
         <p:txBody>
-          <a:bodyPr wrap="square" lIns="0" rIns="0" tIns="0" bIns="0" anchor="t">
+          <a:bodyPr wrap="square" lIns="0" tIns="0" rIns="0" bIns="0" anchor="t">
             <a:spAutoFit/>
           </a:bodyPr>
           <a:lstStyle/>
@@ -11516,7 +11559,7 @@
           <a:noFill/>
         </p:spPr>
         <p:txBody>
-          <a:bodyPr wrap="square" lIns="0" rIns="0" tIns="0" bIns="0" anchor="t">
+          <a:bodyPr wrap="square" lIns="0" tIns="0" rIns="0" bIns="0" anchor="t">
             <a:spAutoFit/>
           </a:bodyPr>
           <a:lstStyle/>
@@ -11558,7 +11601,7 @@
           <a:noFill/>
         </p:spPr>
         <p:txBody>
-          <a:bodyPr wrap="square" lIns="0" rIns="0" tIns="0" bIns="0" anchor="t">
+          <a:bodyPr wrap="square" lIns="0" tIns="0" rIns="0" bIns="0" anchor="t">
             <a:spAutoFit/>
           </a:bodyPr>
           <a:lstStyle/>
@@ -11592,7 +11635,7 @@
 </file>
 
 <file path=ppt/slides/slide9.xml><?xml version="1.0" encoding="utf-8"?>
-<p:sld xmlns:a="http://schemas.openxmlformats.org/drawingml/2006/main" xmlns:p="http://schemas.openxmlformats.org/presentationml/2006/main" xmlns:r="http://schemas.openxmlformats.org/officeDocument/2006/relationships">
+<p:sld xmlns:a="http://schemas.openxmlformats.org/drawingml/2006/main" xmlns:r="http://schemas.openxmlformats.org/officeDocument/2006/relationships" xmlns:p="http://schemas.openxmlformats.org/presentationml/2006/main">
   <p:cSld>
     <p:spTree>
       <p:nvGrpSpPr>
@@ -11600,7 +11643,14 @@
         <p:cNvGrpSpPr/>
         <p:nvPr/>
       </p:nvGrpSpPr>
-      <p:grpSpPr/>
+      <p:grpSpPr>
+        <a:xfrm>
+          <a:off x="0" y="0"/>
+          <a:ext cx="0" cy="0"/>
+          <a:chOff x="0" y="0"/>
+          <a:chExt cx="0" cy="0"/>
+        </a:xfrm>
+      </p:grpSpPr>
       <p:sp>
         <p:nvSpPr>
           <p:cNvPr id="2" name="Rectangle 1"/>
@@ -11640,7 +11690,9 @@
         <p:txBody>
           <a:bodyPr rtlCol="0" anchor="ctr"/>
           <a:lstStyle/>
-          <a:p/>
+          <a:p>
+            <a:endParaRPr/>
+          </a:p>
         </p:txBody>
       </p:sp>
       <p:sp>
@@ -11660,7 +11712,7 @@
           <a:noFill/>
         </p:spPr>
         <p:txBody>
-          <a:bodyPr wrap="square" lIns="0" rIns="0" tIns="0" bIns="0" anchor="t">
+          <a:bodyPr wrap="square" lIns="0" tIns="0" rIns="0" bIns="0" anchor="t">
             <a:spAutoFit/>
           </a:bodyPr>
           <a:lstStyle/>
@@ -11702,7 +11754,7 @@
           <a:noFill/>
         </p:spPr>
         <p:txBody>
-          <a:bodyPr wrap="square" lIns="0" rIns="0" tIns="0" bIns="0" anchor="t">
+          <a:bodyPr wrap="square" lIns="0" tIns="0" rIns="0" bIns="0" anchor="t">
             <a:spAutoFit/>
           </a:bodyPr>
           <a:lstStyle/>
@@ -11744,12 +11796,12 @@
           <a:noFill/>
         </p:spPr>
         <p:txBody>
-          <a:bodyPr wrap="square" lIns="0" rIns="0" tIns="0" bIns="0" anchor="t">
+          <a:bodyPr wrap="square" lIns="0" tIns="0" rIns="0" bIns="0" anchor="t">
             <a:spAutoFit/>
           </a:bodyPr>
           <a:lstStyle/>
           <a:p>
-            <a:pPr algn="l" marL="411480" indent="-411480">
+            <a:pPr marL="411480" indent="-411480" algn="l">
               <a:lnSpc>
                 <a:spcPct val="100000"/>
               </a:lnSpc>
@@ -11786,7 +11838,7 @@
             </a:r>
           </a:p>
           <a:p>
-            <a:pPr algn="l" marL="411480" indent="-411480">
+            <a:pPr marL="411480" indent="-411480" algn="l">
               <a:lnSpc>
                 <a:spcPct val="100000"/>
               </a:lnSpc>
@@ -11823,7 +11875,7 @@
             </a:r>
           </a:p>
           <a:p>
-            <a:pPr algn="l" marL="411480" indent="-411480">
+            <a:pPr marL="411480" indent="-411480" algn="l">
               <a:lnSpc>
                 <a:spcPct val="100000"/>
               </a:lnSpc>
@@ -11860,7 +11912,7 @@
             </a:r>
           </a:p>
           <a:p>
-            <a:pPr algn="l" marL="411480" indent="-411480">
+            <a:pPr marL="411480" indent="-411480" algn="l">
               <a:lnSpc>
                 <a:spcPct val="100000"/>
               </a:lnSpc>
@@ -11897,7 +11949,7 @@
             </a:r>
           </a:p>
           <a:p>
-            <a:pPr algn="l" marL="411480" indent="-411480">
+            <a:pPr marL="411480" indent="-411480" algn="l">
               <a:lnSpc>
                 <a:spcPct val="100000"/>
               </a:lnSpc>
@@ -11934,7 +11986,7 @@
             </a:r>
           </a:p>
           <a:p>
-            <a:pPr algn="l" marL="411480" indent="-411480">
+            <a:pPr marL="411480" indent="-411480" algn="l">
               <a:lnSpc>
                 <a:spcPct val="100000"/>
               </a:lnSpc>
@@ -11971,7 +12023,7 @@
             </a:r>
           </a:p>
           <a:p>
-            <a:pPr algn="l" marL="411480" indent="-411480">
+            <a:pPr marL="411480" indent="-411480" algn="l">
               <a:lnSpc>
                 <a:spcPct val="100000"/>
               </a:lnSpc>
@@ -12008,7 +12060,7 @@
             </a:r>
           </a:p>
           <a:p>
-            <a:pPr algn="l" marL="411480" indent="-411480">
+            <a:pPr marL="411480" indent="-411480" algn="l">
               <a:lnSpc>
                 <a:spcPct val="100000"/>
               </a:lnSpc>
@@ -12045,7 +12097,7 @@
             </a:r>
           </a:p>
           <a:p>
-            <a:pPr algn="l" marL="411480" indent="-411480">
+            <a:pPr marL="411480" indent="-411480" algn="l">
               <a:lnSpc>
                 <a:spcPct val="100000"/>
               </a:lnSpc>
@@ -12082,7 +12134,7 @@
             </a:r>
           </a:p>
           <a:p>
-            <a:pPr algn="l" marL="411480" indent="-411480">
+            <a:pPr marL="411480" indent="-411480" algn="l">
               <a:lnSpc>
                 <a:spcPct val="100000"/>
               </a:lnSpc>
@@ -12119,7 +12171,7 @@
             </a:r>
           </a:p>
           <a:p>
-            <a:pPr algn="l" marL="411480" indent="-411480">
+            <a:pPr marL="411480" indent="-411480" algn="l">
               <a:lnSpc>
                 <a:spcPct val="100000"/>
               </a:lnSpc>
@@ -12209,7 +12261,7 @@
           <a:noFill/>
         </p:spPr>
         <p:txBody>
-          <a:bodyPr wrap="square" lIns="0" rIns="0" tIns="0" bIns="0" anchor="t">
+          <a:bodyPr wrap="square" lIns="0" tIns="0" rIns="0" bIns="0" anchor="t">
             <a:spAutoFit/>
           </a:bodyPr>
           <a:lstStyle/>
@@ -12251,7 +12303,7 @@
           <a:noFill/>
         </p:spPr>
         <p:txBody>
-          <a:bodyPr wrap="square" lIns="0" rIns="0" tIns="0" bIns="0" anchor="t">
+          <a:bodyPr wrap="square" lIns="0" tIns="0" rIns="0" bIns="0" anchor="t">
             <a:spAutoFit/>
           </a:bodyPr>
           <a:lstStyle/>
@@ -12615,44 +12667,44 @@
         <a:sysClr val="window" lastClr="FFFFFF"/>
       </a:lt1>
       <a:dk2>
-        <a:srgbClr val="1F497D"/>
+        <a:srgbClr val="0E2841"/>
       </a:dk2>
       <a:lt2>
-        <a:srgbClr val="EEECE1"/>
+        <a:srgbClr val="E8E8E8"/>
       </a:lt2>
       <a:accent1>
-        <a:srgbClr val="4F81BD"/>
+        <a:srgbClr val="156082"/>
       </a:accent1>
       <a:accent2>
-        <a:srgbClr val="C0504D"/>
+        <a:srgbClr val="E97132"/>
       </a:accent2>
       <a:accent3>
-        <a:srgbClr val="9BBB59"/>
+        <a:srgbClr val="196B24"/>
       </a:accent3>
       <a:accent4>
-        <a:srgbClr val="8064A2"/>
+        <a:srgbClr val="0F9ED5"/>
       </a:accent4>
       <a:accent5>
-        <a:srgbClr val="4BACC6"/>
+        <a:srgbClr val="A02B93"/>
       </a:accent5>
       <a:accent6>
-        <a:srgbClr val="F79646"/>
+        <a:srgbClr val="4EA72E"/>
       </a:accent6>
       <a:hlink>
-        <a:srgbClr val="0000FF"/>
+        <a:srgbClr val="467886"/>
       </a:hlink>
       <a:folHlink>
-        <a:srgbClr val="800080"/>
+        <a:srgbClr val="96607D"/>
       </a:folHlink>
     </a:clrScheme>
     <a:fontScheme name="Office">
       <a:majorFont>
-        <a:latin typeface="Calibri"/>
+        <a:latin typeface="Aptos Display" panose="02110004020202020204"/>
         <a:ea typeface=""/>
         <a:cs typeface=""/>
-        <a:font script="Jpan" typeface="ＭＳ Ｐゴシック"/>
+        <a:font script="Jpan" typeface="游ゴシック Light"/>
         <a:font script="Hang" typeface="맑은 고딕"/>
-        <a:font script="Hans" typeface="宋体"/>
+        <a:font script="Hans" typeface="等线 Light"/>
         <a:font script="Hant" typeface="新細明體"/>
         <a:font script="Arab" typeface="Times New Roman"/>
         <a:font script="Hebr" typeface="Times New Roman"/>
@@ -12680,14 +12732,31 @@
         <a:font script="Viet" typeface="Times New Roman"/>
         <a:font script="Uigh" typeface="Microsoft Uighur"/>
         <a:font script="Geor" typeface="Sylfaen"/>
+        <a:font script="Armn" typeface="Arial"/>
+        <a:font script="Bugi" typeface="Leelawadee UI"/>
+        <a:font script="Bopo" typeface="Microsoft JhengHei"/>
+        <a:font script="Java" typeface="Javanese Text"/>
+        <a:font script="Lisu" typeface="Segoe UI"/>
+        <a:font script="Mymr" typeface="Myanmar Text"/>
+        <a:font script="Nkoo" typeface="Ebrima"/>
+        <a:font script="Olck" typeface="Nirmala UI"/>
+        <a:font script="Osma" typeface="Ebrima"/>
+        <a:font script="Phag" typeface="Phagspa"/>
+        <a:font script="Syrn" typeface="Estrangelo Edessa"/>
+        <a:font script="Syrj" typeface="Estrangelo Edessa"/>
+        <a:font script="Syre" typeface="Estrangelo Edessa"/>
+        <a:font script="Sora" typeface="Nirmala UI"/>
+        <a:font script="Tale" typeface="Microsoft Tai Le"/>
+        <a:font script="Talu" typeface="Microsoft New Tai Lue"/>
+        <a:font script="Tfng" typeface="Ebrima"/>
       </a:majorFont>
       <a:minorFont>
-        <a:latin typeface="Calibri"/>
+        <a:latin typeface="Aptos" panose="02110004020202020204"/>
         <a:ea typeface=""/>
         <a:cs typeface=""/>
-        <a:font script="Jpan" typeface="ＭＳ Ｐゴシック"/>
+        <a:font script="Jpan" typeface="游ゴシック"/>
         <a:font script="Hang" typeface="맑은 고딕"/>
-        <a:font script="Hans" typeface="宋体"/>
+        <a:font script="Hans" typeface="等线"/>
         <a:font script="Hant" typeface="新細明體"/>
         <a:font script="Arab" typeface="Arial"/>
         <a:font script="Hebr" typeface="Arial"/>
@@ -12715,6 +12784,23 @@
         <a:font script="Viet" typeface="Arial"/>
         <a:font script="Uigh" typeface="Microsoft Uighur"/>
         <a:font script="Geor" typeface="Sylfaen"/>
+        <a:font script="Armn" typeface="Arial"/>
+        <a:font script="Bugi" typeface="Leelawadee UI"/>
+        <a:font script="Bopo" typeface="Microsoft JhengHei"/>
+        <a:font script="Java" typeface="Javanese Text"/>
+        <a:font script="Lisu" typeface="Segoe UI"/>
+        <a:font script="Mymr" typeface="Myanmar Text"/>
+        <a:font script="Nkoo" typeface="Ebrima"/>
+        <a:font script="Olck" typeface="Nirmala UI"/>
+        <a:font script="Osma" typeface="Ebrima"/>
+        <a:font script="Phag" typeface="Phagspa"/>
+        <a:font script="Syrn" typeface="Estrangelo Edessa"/>
+        <a:font script="Syrj" typeface="Estrangelo Edessa"/>
+        <a:font script="Syre" typeface="Estrangelo Edessa"/>
+        <a:font script="Sora" typeface="Nirmala UI"/>
+        <a:font script="Tale" typeface="Microsoft Tai Le"/>
+        <a:font script="Talu" typeface="Microsoft New Tai Lue"/>
+        <a:font script="Tfng" typeface="Ebrima"/>
       </a:minorFont>
     </a:fontScheme>
     <a:fmtScheme name="Office">
@@ -12726,180 +12812,136 @@
           <a:gsLst>
             <a:gs pos="0">
               <a:schemeClr val="phClr">
-                <a:tint val="50000"/>
-                <a:satMod val="300000"/>
+                <a:lumMod val="110000"/>
+                <a:satMod val="105000"/>
+                <a:tint val="67000"/>
               </a:schemeClr>
             </a:gs>
-            <a:gs pos="35000">
+            <a:gs pos="50000">
               <a:schemeClr val="phClr">
-                <a:tint val="37000"/>
-                <a:satMod val="300000"/>
+                <a:lumMod val="105000"/>
+                <a:satMod val="103000"/>
+                <a:tint val="73000"/>
               </a:schemeClr>
             </a:gs>
             <a:gs pos="100000">
               <a:schemeClr val="phClr">
-                <a:tint val="15000"/>
-                <a:satMod val="350000"/>
+                <a:lumMod val="105000"/>
+                <a:satMod val="109000"/>
+                <a:tint val="81000"/>
               </a:schemeClr>
             </a:gs>
           </a:gsLst>
-          <a:lin ang="16200000" scaled="1"/>
+          <a:lin ang="5400000" scaled="0"/>
         </a:gradFill>
         <a:gradFill rotWithShape="1">
           <a:gsLst>
             <a:gs pos="0">
               <a:schemeClr val="phClr">
-                <a:tint val="100000"/>
+                <a:satMod val="103000"/>
+                <a:lumMod val="102000"/>
+                <a:tint val="94000"/>
+              </a:schemeClr>
+            </a:gs>
+            <a:gs pos="50000">
+              <a:schemeClr val="phClr">
+                <a:satMod val="110000"/>
+                <a:lumMod val="100000"/>
                 <a:shade val="100000"/>
-                <a:satMod val="130000"/>
               </a:schemeClr>
             </a:gs>
             <a:gs pos="100000">
               <a:schemeClr val="phClr">
-                <a:tint val="50000"/>
-                <a:shade val="100000"/>
-                <a:satMod val="350000"/>
+                <a:lumMod val="99000"/>
+                <a:satMod val="120000"/>
+                <a:shade val="78000"/>
               </a:schemeClr>
             </a:gs>
           </a:gsLst>
-          <a:lin ang="16200000" scaled="0"/>
+          <a:lin ang="5400000" scaled="0"/>
         </a:gradFill>
       </a:fillStyleLst>
       <a:lnStyleLst>
-        <a:ln w="9525" cap="flat" cmpd="sng" algn="ctr">
+        <a:ln w="12700" cap="flat" cmpd="sng" algn="ctr">
           <a:solidFill>
-            <a:schemeClr val="phClr">
-              <a:shade val="95000"/>
-              <a:satMod val="105000"/>
-            </a:schemeClr>
+            <a:schemeClr val="phClr"/>
           </a:solidFill>
           <a:prstDash val="solid"/>
+          <a:miter lim="800000"/>
+        </a:ln>
+        <a:ln w="19050" cap="flat" cmpd="sng" algn="ctr">
+          <a:solidFill>
+            <a:schemeClr val="phClr"/>
+          </a:solidFill>
+          <a:prstDash val="solid"/>
+          <a:miter lim="800000"/>
         </a:ln>
         <a:ln w="25400" cap="flat" cmpd="sng" algn="ctr">
           <a:solidFill>
             <a:schemeClr val="phClr"/>
           </a:solidFill>
           <a:prstDash val="solid"/>
-        </a:ln>
-        <a:ln w="38100" cap="flat" cmpd="sng" algn="ctr">
-          <a:solidFill>
-            <a:schemeClr val="phClr"/>
-          </a:solidFill>
-          <a:prstDash val="solid"/>
+          <a:miter lim="800000"/>
         </a:ln>
       </a:lnStyleLst>
       <a:effectStyleLst>
         <a:effectStyle>
+          <a:effectLst/>
+        </a:effectStyle>
+        <a:effectStyle>
+          <a:effectLst/>
+        </a:effectStyle>
+        <a:effectStyle>
           <a:effectLst>
-            <a:outerShdw blurRad="40000" dist="20000" dir="5400000" rotWithShape="0">
+            <a:outerShdw blurRad="57150" dist="19050" dir="5400000" algn="ctr" rotWithShape="0">
               <a:srgbClr val="000000">
-                <a:alpha val="38000"/>
+                <a:alpha val="63000"/>
               </a:srgbClr>
             </a:outerShdw>
           </a:effectLst>
-        </a:effectStyle>
-        <a:effectStyle>
-          <a:effectLst>
-            <a:outerShdw blurRad="40000" dist="23000" dir="5400000" rotWithShape="0">
-              <a:srgbClr val="000000">
-                <a:alpha val="35000"/>
-              </a:srgbClr>
-            </a:outerShdw>
-          </a:effectLst>
-        </a:effectStyle>
-        <a:effectStyle>
-          <a:effectLst>
-            <a:outerShdw blurRad="40000" dist="23000" dir="5400000" rotWithShape="0">
-              <a:srgbClr val="000000">
-                <a:alpha val="35000"/>
-              </a:srgbClr>
-            </a:outerShdw>
-          </a:effectLst>
-          <a:scene3d>
-            <a:camera prst="orthographicFront">
-              <a:rot lat="0" lon="0" rev="0"/>
-            </a:camera>
-            <a:lightRig rig="threePt" dir="t">
-              <a:rot lat="0" lon="0" rev="1200000"/>
-            </a:lightRig>
-          </a:scene3d>
-          <a:sp3d>
-            <a:bevelT w="63500" h="25400"/>
-          </a:sp3d>
         </a:effectStyle>
       </a:effectStyleLst>
       <a:bgFillStyleLst>
         <a:solidFill>
           <a:schemeClr val="phClr"/>
         </a:solidFill>
+        <a:solidFill>
+          <a:schemeClr val="phClr">
+            <a:tint val="95000"/>
+            <a:satMod val="170000"/>
+          </a:schemeClr>
+        </a:solidFill>
         <a:gradFill rotWithShape="1">
           <a:gsLst>
             <a:gs pos="0">
               <a:schemeClr val="phClr">
-                <a:tint val="40000"/>
-                <a:satMod val="350000"/>
+                <a:tint val="93000"/>
+                <a:satMod val="150000"/>
+                <a:shade val="98000"/>
+                <a:lumMod val="102000"/>
               </a:schemeClr>
             </a:gs>
-            <a:gs pos="40000">
+            <a:gs pos="50000">
               <a:schemeClr val="phClr">
-                <a:tint val="45000"/>
-                <a:shade val="99000"/>
-                <a:satMod val="350000"/>
+                <a:tint val="98000"/>
+                <a:satMod val="130000"/>
+                <a:shade val="90000"/>
+                <a:lumMod val="103000"/>
               </a:schemeClr>
             </a:gs>
             <a:gs pos="100000">
               <a:schemeClr val="phClr">
-                <a:shade val="20000"/>
-                <a:satMod val="255000"/>
+                <a:shade val="63000"/>
+                <a:satMod val="120000"/>
               </a:schemeClr>
             </a:gs>
           </a:gsLst>
-          <a:path path="circle">
-            <a:fillToRect l="50000" t="-80000" r="50000" b="180000"/>
-          </a:path>
-        </a:gradFill>
-        <a:gradFill rotWithShape="1">
-          <a:gsLst>
-            <a:gs pos="0">
-              <a:schemeClr val="phClr">
-                <a:tint val="80000"/>
-                <a:satMod val="300000"/>
-              </a:schemeClr>
-            </a:gs>
-            <a:gs pos="100000">
-              <a:schemeClr val="phClr">
-                <a:shade val="30000"/>
-                <a:satMod val="200000"/>
-              </a:schemeClr>
-            </a:gs>
-          </a:gsLst>
-          <a:path path="circle">
-            <a:fillToRect l="50000" t="50000" r="50000" b="50000"/>
-          </a:path>
+          <a:lin ang="5400000" scaled="0"/>
         </a:gradFill>
       </a:bgFillStyleLst>
     </a:fmtScheme>
   </a:themeElements>
   <a:objectDefaults>
-    <a:spDef>
-      <a:spPr/>
-      <a:bodyPr/>
-      <a:lstStyle/>
-      <a:style>
-        <a:lnRef idx="1">
-          <a:schemeClr val="accent1"/>
-        </a:lnRef>
-        <a:fillRef idx="3">
-          <a:schemeClr val="accent1"/>
-        </a:fillRef>
-        <a:effectRef idx="2">
-          <a:schemeClr val="accent1"/>
-        </a:effectRef>
-        <a:fontRef idx="minor">
-          <a:schemeClr val="lt1"/>
-        </a:fontRef>
-      </a:style>
-    </a:spDef>
     <a:lnDef>
       <a:spPr/>
       <a:bodyPr/>
@@ -12921,5 +12963,10 @@
     </a:lnDef>
   </a:objectDefaults>
   <a:extraClrSchemeLst/>
+  <a:extLst>
+    <a:ext uri="{05A4C25C-085E-4340-85A3-A5531E510DB2}">
+      <thm15:themeFamily xmlns:thm15="http://schemas.microsoft.com/office/thememl/2012/main" name="Office Theme" id="{2E142A2C-CD16-42D6-873A-C26D2A0506FA}" vid="{1BDDFF52-6CD6-40A5-AB3C-68EB2F1E4D0A}"/>
+    </a:ext>
+  </a:extLst>
 </a:theme>
 </file>
</xml_diff>